<commit_message>
feat(ia-pep-2): regeneration S02 panorama au nouveau format
</commit_message>
<xml_diff>
--- a/ia-pep-2/seance-02/presentation.pptx
+++ b/ia-pep-2/seance-02/presentation.pptx
@@ -16,6 +16,10 @@
     <p:sldId id="264" r:id="rId15"/>
     <p:sldId id="265" r:id="rId16"/>
     <p:sldId id="266" r:id="rId17"/>
+    <p:sldId id="267" r:id="rId18"/>
+    <p:sldId id="268" r:id="rId19"/>
+    <p:sldId id="269" r:id="rId20"/>
+    <p:sldId id="270" r:id="rId21"/>
   </p:sldIdLst>
   <p:sldSz cx="12191695" cy="6858000" type="screen4x3"/>
   <p:notesSz cx="6858000" cy="9144000"/>
@@ -3114,7 +3118,7 @@
         </p:nvSpPr>
         <p:spPr>
           <a:xfrm>
-            <a:off x="822960" y="2011680"/>
+            <a:off x="822960" y="1828800"/>
             <a:ext cx="10515600" cy="1828800"/>
           </a:xfrm>
           <a:prstGeom prst="rect">
@@ -3129,22 +3133,22 @@
           <a:lstStyle/>
           <a:p>
             <a:r>
-              <a:rPr sz="4400" b="1">
+              <a:rPr sz="4000" b="1">
                 <a:solidFill>
                   <a:srgbClr val="FFFFFF"/>
                 </a:solidFill>
               </a:rPr>
-              <a:t>Séance 02 — Panorama des outils d'IA pour l'enseignant</a:t>
-            </a:r>
-          </a:p>
-          <a:p>
-            <a:r>
-              <a:rPr sz="2200">
+              <a:t>Séance 02 — Panorama des 12+ outils d'IA pour l'étudiant</a:t>
+            </a:r>
+          </a:p>
+          <a:p>
+            <a:r>
+              <a:rPr sz="2000">
                 <a:solidFill>
                   <a:srgbClr val="ECEFF1"/>
                 </a:solidFill>
               </a:rPr>
-              <a:t>Overview of AI tools for the teacher</a:t>
+              <a:t>Overview of 12+ AI tools for students</a:t>
             </a:r>
           </a:p>
         </p:txBody>
@@ -3157,8 +3161,8 @@
         </p:nvSpPr>
         <p:spPr>
           <a:xfrm>
-            <a:off x="822960" y="4114800"/>
-            <a:ext cx="10515600" cy="1371600"/>
+            <a:off x="822960" y="4023360"/>
+            <a:ext cx="10515600" cy="1463040"/>
           </a:xfrm>
           <a:prstGeom prst="rect">
             <a:avLst/>
@@ -3172,7 +3176,7 @@
           <a:lstStyle/>
           <a:p>
             <a:r>
-              <a:rPr sz="1600">
+              <a:rPr sz="1500">
                 <a:solidFill>
                   <a:srgbClr val="ECEFF1"/>
                 </a:solidFill>
@@ -3217,10 +3221,10 @@
           <a:lstStyle/>
           <a:p>
             <a:r>
-              <a:t>À retenir</a:t>
-            </a:r>
-            <a:r>
-              <a:t>  ·  Key takeaways</a:t>
+              <a:t>📺 À regarder pour comprendre</a:t>
+            </a:r>
+            <a:r>
+              <a:t>  ·  Recommended videos</a:t>
             </a:r>
           </a:p>
         </p:txBody>
@@ -3241,83 +3245,75 @@
           <a:lstStyle/>
           <a:p>
             <a:pPr>
-              <a:defRPr sz="2200"/>
-            </a:pPr>
-            <a:r>
-              <a:t>Six familles d'outils : texte, images, voix, quiz, présentation, vidéo.</a:t>
-            </a:r>
-          </a:p>
-          <a:p>
-            <a:pPr>
-              <a:defRPr sz="2200"/>
-            </a:pPr>
-            <a:r>
-              <a:t>On choisit un outil selon la tâche, le public, le coût, la protection des données et la vérification.</a:t>
-            </a:r>
-          </a:p>
-          <a:p>
-            <a:pPr>
-              <a:defRPr sz="2200"/>
-            </a:pPr>
-            <a:r>
-              <a:t>Pas d'outil sans vérification : l'enseignant garde le dernier mot.</a:t>
-            </a:r>
-          </a:p>
-          <a:p>
-            <a:pPr>
-              <a:defRPr sz="2200"/>
-            </a:pPr>
-            <a:r>
-              <a:t>La version gratuite suffit souvent pour une classe ; toujours tester sur un appareil d'élève.</a:t>
+              <a:defRPr sz="2000"/>
+            </a:pPr>
+            <a:r>
+              <a:t>▶️ Playlist IA de Mohammad Dawoud (référence du module) (ar)</a:t>
+            </a:r>
+          </a:p>
+          <a:p>
+            <a:pPr>
+              <a:defRPr sz="2000"/>
+            </a:pPr>
+            <a:r>
+              <a:t>▶️ Comparatif assistants IA 2026 : lequel choisir ? (fr)</a:t>
+            </a:r>
+          </a:p>
+          <a:p>
+            <a:pPr>
+              <a:defRPr sz="2000"/>
+            </a:pPr>
+            <a:r>
+              <a:t>▶️ 10 outils IA pour étudiants : panorama guidé (fr)</a:t>
             </a:r>
           </a:p>
           <a:p/>
           <a:p>
+            <a:pPr>
+              <a:defRPr sz="1300" i="1">
+                <a:solidFill>
+                  <a:srgbClr val="78899C"/>
+                </a:solidFill>
+              </a:defRPr>
+            </a:pPr>
+            <a:r>
+              <a:t>English summary:</a:t>
+            </a:r>
+          </a:p>
+          <a:p>
             <a:pPr lvl="1">
-              <a:defRPr sz="1400">
+              <a:defRPr sz="1300">
                 <a:solidFill>
                   <a:srgbClr val="546E7A"/>
                 </a:solidFill>
               </a:defRPr>
             </a:pPr>
             <a:r>
-              <a:t>• Six tool families: text, images, voice, quizzes, presentation, video.</a:t>
+              <a:t>• https://www.youtube.com/watch?v=H5WUwwivEaI&amp;list=PLbR_CTcUs1088jfqbbO5AqwODO9MgYA85</a:t>
             </a:r>
           </a:p>
           <a:p>
             <a:pPr lvl="1">
-              <a:defRPr sz="1400">
+              <a:defRPr sz="1300">
                 <a:solidFill>
                   <a:srgbClr val="546E7A"/>
                 </a:solidFill>
               </a:defRPr>
             </a:pPr>
             <a:r>
-              <a:t>• Choose a tool according to the task, the audience, cost, data protection and verification.</a:t>
+              <a:t>• https://www.youtube.com/results?search_query=comparatif+chatgpt+gemini+claude+2026+francais</a:t>
             </a:r>
           </a:p>
           <a:p>
             <a:pPr lvl="1">
-              <a:defRPr sz="1400">
+              <a:defRPr sz="1300">
                 <a:solidFill>
                   <a:srgbClr val="546E7A"/>
                 </a:solidFill>
               </a:defRPr>
             </a:pPr>
             <a:r>
-              <a:t>• No tool without checking: the teacher has the final word.</a:t>
-            </a:r>
-          </a:p>
-          <a:p>
-            <a:pPr lvl="1">
-              <a:defRPr sz="1400">
-                <a:solidFill>
-                  <a:srgbClr val="546E7A"/>
-                </a:solidFill>
-              </a:defRPr>
-            </a:pPr>
-            <a:r>
-              <a:t>• The free version is often enough for a class; always test on a pupil's device.</a:t>
+              <a:t>• https://www.youtube.com/results?search_query=outils+ia+etudiants+universite+tutoriel</a:t>
             </a:r>
           </a:p>
         </p:txBody>
@@ -3331,6 +3327,594 @@
 </file>
 
 <file path=ppt/slides/slide11.xml><?xml version="1.0" encoding="utf-8"?>
+<p:sld xmlns:a="http://schemas.openxmlformats.org/drawingml/2006/main" xmlns:p="http://schemas.openxmlformats.org/presentationml/2006/main" xmlns:r="http://schemas.openxmlformats.org/officeDocument/2006/relationships">
+  <p:cSld>
+    <p:spTree>
+      <p:nvGrpSpPr>
+        <p:cNvPr id="1" name=""/>
+        <p:cNvGrpSpPr/>
+        <p:nvPr/>
+      </p:nvGrpSpPr>
+      <p:grpSpPr/>
+      <p:sp>
+        <p:nvSpPr>
+          <p:cNvPr id="2" name="Title 1"/>
+          <p:cNvSpPr>
+            <a:spLocks noGrp="1"/>
+          </p:cNvSpPr>
+          <p:nvPr>
+            <p:ph type="title"/>
+          </p:nvPr>
+        </p:nvSpPr>
+        <p:spPr/>
+        <p:txBody>
+          <a:bodyPr/>
+          <a:lstStyle/>
+          <a:p>
+            <a:r>
+              <a:t>✏️ Exercice guidé (15 min)</a:t>
+            </a:r>
+            <a:r>
+              <a:t>  ·  Guided exercise</a:t>
+            </a:r>
+          </a:p>
+        </p:txBody>
+      </p:sp>
+      <p:sp>
+        <p:nvSpPr>
+          <p:cNvPr id="3" name="Content Placeholder 2"/>
+          <p:cNvSpPr>
+            <a:spLocks noGrp="1"/>
+          </p:cNvSpPr>
+          <p:nvPr>
+            <p:ph idx="1"/>
+          </p:nvPr>
+        </p:nvSpPr>
+        <p:spPr/>
+        <p:txBody>
+          <a:bodyPr wrap="square"/>
+          <a:lstStyle/>
+          <a:p>
+            <a:pPr>
+              <a:defRPr sz="2000"/>
+            </a:pPr>
+            <a:r>
+              <a:t>8 situations d'étudiant : prescrivez le bon outil avec l'arbre de décision (sources ? créer ? organiser-coder ?). Justifiez en 1 phrase.</a:t>
+            </a:r>
+          </a:p>
+          <a:p>
+            <a:pPr>
+              <a:defRPr sz="2000"/>
+            </a:pPr>
+            <a:r>
+              <a:t>—</a:t>
+            </a:r>
+          </a:p>
+          <a:p>
+            <a:pPr>
+              <a:defRPr sz="2000"/>
+            </a:pPr>
+            <a:r>
+              <a:t>▶ Solution :</a:t>
+            </a:r>
+          </a:p>
+          <a:p>
+            <a:pPr>
+              <a:defRPr sz="2000"/>
+            </a:pPr>
+            <a:r>
+              <a:t>1) Expliquer une notion → 🔵 ChatGPT. 2) Citer 2 études → 🟢 Perplexity/Scholar. 3) Slides d'exposé → 🟠 Gamma. 4) Affiche → 🟠 Canva. 5) Planning révisions → 🟣 Notion. 6) Bug Python → 🟣 Copilot. 7) Résumer VOS PDF → 🟢 NotebookLM. 8) Chatbot sans code → 🟣 Dify.</a:t>
+            </a:r>
+          </a:p>
+          <a:p/>
+          <a:p>
+            <a:pPr>
+              <a:defRPr sz="1300" i="1">
+                <a:solidFill>
+                  <a:srgbClr val="78899C"/>
+                </a:solidFill>
+              </a:defRPr>
+            </a:pPr>
+            <a:r>
+              <a:t>English summary:</a:t>
+            </a:r>
+          </a:p>
+          <a:p>
+            <a:pPr lvl="1">
+              <a:defRPr sz="1300">
+                <a:solidFill>
+                  <a:srgbClr val="546E7A"/>
+                </a:solidFill>
+              </a:defRPr>
+            </a:pPr>
+            <a:r>
+              <a:t>• 8 student situations: prescribe the right tool with the decision tree (sources? create? organise-code?). Justify in 1 sentence.</a:t>
+            </a:r>
+          </a:p>
+          <a:p>
+            <a:pPr lvl="1">
+              <a:defRPr sz="1300">
+                <a:solidFill>
+                  <a:srgbClr val="546E7A"/>
+                </a:solidFill>
+              </a:defRPr>
+            </a:pPr>
+            <a:r>
+              <a:t>• 1) Explain a notion → 🔵 ChatGPT. 2) Cite 2 studies → 🟢 Perplexity/Scholar. 3) Talk slides → 🟠 Gamma. 4) Poster → 🟠 Canva. 5) Revision plan → 🟣 Notion. 6) Python bug → 🟣 Copilot. 7) Summarise YOUR PDFs → 🟢 NotebookLM. 8) No-code chatbot → 🟣 Dify.</a:t>
+            </a:r>
+          </a:p>
+        </p:txBody>
+      </p:sp>
+    </p:spTree>
+  </p:cSld>
+  <p:clrMapOvr>
+    <a:masterClrMapping/>
+  </p:clrMapOvr>
+</p:sld>
+</file>
+
+<file path=ppt/slides/slide12.xml><?xml version="1.0" encoding="utf-8"?>
+<p:sld xmlns:a="http://schemas.openxmlformats.org/drawingml/2006/main" xmlns:p="http://schemas.openxmlformats.org/presentationml/2006/main" xmlns:r="http://schemas.openxmlformats.org/officeDocument/2006/relationships">
+  <p:cSld>
+    <p:spTree>
+      <p:nvGrpSpPr>
+        <p:cNvPr id="1" name=""/>
+        <p:cNvGrpSpPr/>
+        <p:nvPr/>
+      </p:nvGrpSpPr>
+      <p:grpSpPr/>
+      <p:sp>
+        <p:nvSpPr>
+          <p:cNvPr id="2" name="Title 1"/>
+          <p:cNvSpPr>
+            <a:spLocks noGrp="1"/>
+          </p:cNvSpPr>
+          <p:nvPr>
+            <p:ph type="title"/>
+          </p:nvPr>
+        </p:nvSpPr>
+        <p:spPr/>
+        <p:txBody>
+          <a:bodyPr/>
+          <a:lstStyle/>
+          <a:p>
+            <a:r>
+              <a:t>🧠 Fiche de synthèse — points clés</a:t>
+            </a:r>
+            <a:r>
+              <a:t>  ·  Summary sheet</a:t>
+            </a:r>
+          </a:p>
+        </p:txBody>
+      </p:sp>
+      <p:sp>
+        <p:nvSpPr>
+          <p:cNvPr id="3" name="Content Placeholder 2"/>
+          <p:cNvSpPr>
+            <a:spLocks noGrp="1"/>
+          </p:cNvSpPr>
+          <p:nvPr>
+            <p:ph idx="1"/>
+          </p:nvPr>
+        </p:nvSpPr>
+        <p:spPr/>
+        <p:txBody>
+          <a:bodyPr wrap="square"/>
+          <a:lstStyle/>
+          <a:p>
+            <a:pPr>
+              <a:defRPr sz="2000"/>
+            </a:pPr>
+            <a:r>
+              <a:t>4 tiroirs : 🔵 comprendre, 🟢 chercher, 🟠 créer, 🟣 organiser-coder.</a:t>
+            </a:r>
+          </a:p>
+          <a:p>
+            <a:pPr>
+              <a:defRPr sz="2000"/>
+            </a:pPr>
+            <a:r>
+              <a:t>Arbre : sources ? → créer ? → organiser-coder ? → sinon bleu.</a:t>
+            </a:r>
+          </a:p>
+          <a:p>
+            <a:pPr>
+              <a:defRPr sz="2000"/>
+            </a:pPr>
+            <a:r>
+              <a:t>1 favori par tiroir + page Outils IA en favori.</a:t>
+            </a:r>
+          </a:p>
+          <a:p>
+            <a:pPr>
+              <a:defRPr sz="2000"/>
+            </a:pPr>
+            <a:r>
+              <a:t>Gratuit étudiant d'abord, jamais d'abonnement aveugle.</a:t>
+            </a:r>
+          </a:p>
+          <a:p>
+            <a:pPr>
+              <a:defRPr sz="2000"/>
+            </a:pPr>
+            <a:r>
+              <a:t>3 règles d'or partout : vérifier, citer, juger.</a:t>
+            </a:r>
+          </a:p>
+          <a:p/>
+          <a:p>
+            <a:pPr>
+              <a:defRPr sz="1300" i="1">
+                <a:solidFill>
+                  <a:srgbClr val="78899C"/>
+                </a:solidFill>
+              </a:defRPr>
+            </a:pPr>
+            <a:r>
+              <a:t>English summary:</a:t>
+            </a:r>
+          </a:p>
+          <a:p>
+            <a:pPr lvl="1">
+              <a:defRPr sz="1300">
+                <a:solidFill>
+                  <a:srgbClr val="546E7A"/>
+                </a:solidFill>
+              </a:defRPr>
+            </a:pPr>
+            <a:r>
+              <a:t>• 4 drawers: 🔵 understand, 🟢 search, 🟠 create, 🟣 organise-code.</a:t>
+            </a:r>
+          </a:p>
+          <a:p>
+            <a:pPr lvl="1">
+              <a:defRPr sz="1300">
+                <a:solidFill>
+                  <a:srgbClr val="546E7A"/>
+                </a:solidFill>
+              </a:defRPr>
+            </a:pPr>
+            <a:r>
+              <a:t>• Tree: sources? → create? → organise-code? → else blue.</a:t>
+            </a:r>
+          </a:p>
+          <a:p>
+            <a:pPr lvl="1">
+              <a:defRPr sz="1300">
+                <a:solidFill>
+                  <a:srgbClr val="546E7A"/>
+                </a:solidFill>
+              </a:defRPr>
+            </a:pPr>
+            <a:r>
+              <a:t>• 1 favourite per drawer + AI Tools page bookmarked.</a:t>
+            </a:r>
+          </a:p>
+        </p:txBody>
+      </p:sp>
+    </p:spTree>
+  </p:cSld>
+  <p:clrMapOvr>
+    <a:masterClrMapping/>
+  </p:clrMapOvr>
+</p:sld>
+</file>
+
+<file path=ppt/slides/slide13.xml><?xml version="1.0" encoding="utf-8"?>
+<p:sld xmlns:a="http://schemas.openxmlformats.org/drawingml/2006/main" xmlns:p="http://schemas.openxmlformats.org/presentationml/2006/main" xmlns:r="http://schemas.openxmlformats.org/officeDocument/2006/relationships">
+  <p:cSld>
+    <p:spTree>
+      <p:nvGrpSpPr>
+        <p:cNvPr id="1" name=""/>
+        <p:cNvGrpSpPr/>
+        <p:nvPr/>
+      </p:nvGrpSpPr>
+      <p:grpSpPr/>
+      <p:sp>
+        <p:nvSpPr>
+          <p:cNvPr id="2" name="Title 1"/>
+          <p:cNvSpPr>
+            <a:spLocks noGrp="1"/>
+          </p:cNvSpPr>
+          <p:nvPr>
+            <p:ph type="title"/>
+          </p:nvPr>
+        </p:nvSpPr>
+        <p:spPr/>
+        <p:txBody>
+          <a:bodyPr/>
+          <a:lstStyle/>
+          <a:p>
+            <a:r>
+              <a:t>🧠 Quiz éclair (3 questions)</a:t>
+            </a:r>
+            <a:r>
+              <a:t>  ·  Quick quiz</a:t>
+            </a:r>
+          </a:p>
+        </p:txBody>
+      </p:sp>
+      <p:sp>
+        <p:nvSpPr>
+          <p:cNvPr id="3" name="Content Placeholder 2"/>
+          <p:cNvSpPr>
+            <a:spLocks noGrp="1"/>
+          </p:cNvSpPr>
+          <p:nvPr>
+            <p:ph idx="1"/>
+          </p:nvPr>
+        </p:nvSpPr>
+        <p:spPr/>
+        <p:txBody>
+          <a:bodyPr wrap="square"/>
+          <a:lstStyle/>
+          <a:p>
+            <a:pPr>
+              <a:defRPr sz="2000"/>
+            </a:pPr>
+            <a:r>
+              <a:t>Q1. Besoin de SOURCES : quel tiroir ?</a:t>
+            </a:r>
+            <a:br/>
+            <a:r>
+              <a:t>   ✅ 🟢 Vert (Perplexity, Scholar)</a:t>
+            </a:r>
+          </a:p>
+          <a:p>
+            <a:pPr>
+              <a:defRPr sz="2000"/>
+            </a:pPr>
+            <a:r>
+              <a:t>Q2. Slides d'exposé : quel outil ?</a:t>
+            </a:r>
+            <a:br/>
+            <a:r>
+              <a:t>   ✅ Gamma (créer à montrer)</a:t>
+            </a:r>
+          </a:p>
+          <a:p>
+            <a:pPr>
+              <a:defRPr sz="2000"/>
+            </a:pPr>
+            <a:r>
+              <a:t>Q3. Interroger VOS propres PDF : quel outil ?</a:t>
+            </a:r>
+            <a:br/>
+            <a:r>
+              <a:t>   ✅ NotebookLM (vert : chercher dans vos documents)</a:t>
+            </a:r>
+          </a:p>
+          <a:p/>
+          <a:p>
+            <a:pPr>
+              <a:defRPr sz="1300" i="1">
+                <a:solidFill>
+                  <a:srgbClr val="78899C"/>
+                </a:solidFill>
+              </a:defRPr>
+            </a:pPr>
+            <a:r>
+              <a:t>English summary:</a:t>
+            </a:r>
+          </a:p>
+          <a:p>
+            <a:pPr lvl="1">
+              <a:defRPr sz="1300">
+                <a:solidFill>
+                  <a:srgbClr val="546E7A"/>
+                </a:solidFill>
+              </a:defRPr>
+            </a:pPr>
+            <a:r>
+              <a:t>• Need SOURCES: which drawer?</a:t>
+            </a:r>
+          </a:p>
+          <a:p>
+            <a:pPr lvl="1">
+              <a:defRPr sz="1300">
+                <a:solidFill>
+                  <a:srgbClr val="546E7A"/>
+                </a:solidFill>
+              </a:defRPr>
+            </a:pPr>
+            <a:r>
+              <a:t>• Talk slides: which tool?</a:t>
+            </a:r>
+          </a:p>
+          <a:p>
+            <a:pPr lvl="1">
+              <a:defRPr sz="1300">
+                <a:solidFill>
+                  <a:srgbClr val="546E7A"/>
+                </a:solidFill>
+              </a:defRPr>
+            </a:pPr>
+            <a:r>
+              <a:t>• Question YOUR own PDFs: which tool?</a:t>
+            </a:r>
+          </a:p>
+        </p:txBody>
+      </p:sp>
+    </p:spTree>
+  </p:cSld>
+  <p:clrMapOvr>
+    <a:masterClrMapping/>
+  </p:clrMapOvr>
+</p:sld>
+</file>
+
+<file path=ppt/slides/slide14.xml><?xml version="1.0" encoding="utf-8"?>
+<p:sld xmlns:a="http://schemas.openxmlformats.org/drawingml/2006/main" xmlns:p="http://schemas.openxmlformats.org/presentationml/2006/main" xmlns:r="http://schemas.openxmlformats.org/officeDocument/2006/relationships">
+  <p:cSld>
+    <p:spTree>
+      <p:nvGrpSpPr>
+        <p:cNvPr id="1" name=""/>
+        <p:cNvGrpSpPr/>
+        <p:nvPr/>
+      </p:nvGrpSpPr>
+      <p:grpSpPr/>
+      <p:sp>
+        <p:nvSpPr>
+          <p:cNvPr id="2" name="Title 1"/>
+          <p:cNvSpPr>
+            <a:spLocks noGrp="1"/>
+          </p:cNvSpPr>
+          <p:nvPr>
+            <p:ph type="title"/>
+          </p:nvPr>
+        </p:nvSpPr>
+        <p:spPr/>
+        <p:txBody>
+          <a:bodyPr/>
+          <a:lstStyle/>
+          <a:p>
+            <a:r>
+              <a:t>À retenir</a:t>
+            </a:r>
+            <a:r>
+              <a:t>  ·  Key takeaways</a:t>
+            </a:r>
+          </a:p>
+        </p:txBody>
+      </p:sp>
+      <p:sp>
+        <p:nvSpPr>
+          <p:cNvPr id="3" name="Content Placeholder 2"/>
+          <p:cNvSpPr>
+            <a:spLocks noGrp="1"/>
+          </p:cNvSpPr>
+          <p:nvPr>
+            <p:ph idx="1"/>
+          </p:nvPr>
+        </p:nvSpPr>
+        <p:spPr/>
+        <p:txBody>
+          <a:bodyPr wrap="square"/>
+          <a:lstStyle/>
+          <a:p>
+            <a:pPr>
+              <a:defRPr sz="2000"/>
+            </a:pPr>
+            <a:r>
+              <a:t>4 tiroirs : 🔵🟢🟠🟣 valent mieux que 12 noms.</a:t>
+            </a:r>
+          </a:p>
+          <a:p>
+            <a:pPr>
+              <a:defRPr sz="2000"/>
+            </a:pPr>
+            <a:r>
+              <a:t>Arbre : sources ? créer ? organiser-coder ? sinon bleu.</a:t>
+            </a:r>
+          </a:p>
+          <a:p>
+            <a:pPr>
+              <a:defRPr sz="2000"/>
+            </a:pPr>
+            <a:r>
+              <a:t>Démo : même question, 3 outils, 3 métiers.</a:t>
+            </a:r>
+          </a:p>
+          <a:p>
+            <a:pPr>
+              <a:defRPr sz="2000"/>
+            </a:pPr>
+            <a:r>
+              <a:t>Gratuit étudiant d'abord ; 3 règles d'or partout.</a:t>
+            </a:r>
+          </a:p>
+          <a:p>
+            <a:pPr>
+              <a:defRPr sz="2000"/>
+            </a:pPr>
+            <a:r>
+              <a:t>Page Outils IA en favori : la pharmacie de poche.</a:t>
+            </a:r>
+          </a:p>
+          <a:p/>
+          <a:p>
+            <a:pPr>
+              <a:defRPr sz="1300" i="1">
+                <a:solidFill>
+                  <a:srgbClr val="78899C"/>
+                </a:solidFill>
+              </a:defRPr>
+            </a:pPr>
+            <a:r>
+              <a:t>English summary:</a:t>
+            </a:r>
+          </a:p>
+          <a:p>
+            <a:pPr lvl="1">
+              <a:defRPr sz="1300">
+                <a:solidFill>
+                  <a:srgbClr val="546E7A"/>
+                </a:solidFill>
+              </a:defRPr>
+            </a:pPr>
+            <a:r>
+              <a:t>• 4 drawers: 🔵🟢🟠🟣 beat 12 names.</a:t>
+            </a:r>
+          </a:p>
+          <a:p>
+            <a:pPr lvl="1">
+              <a:defRPr sz="1300">
+                <a:solidFill>
+                  <a:srgbClr val="546E7A"/>
+                </a:solidFill>
+              </a:defRPr>
+            </a:pPr>
+            <a:r>
+              <a:t>• Tree: sources? create? organise-code? else blue.</a:t>
+            </a:r>
+          </a:p>
+          <a:p>
+            <a:pPr lvl="1">
+              <a:defRPr sz="1300">
+                <a:solidFill>
+                  <a:srgbClr val="546E7A"/>
+                </a:solidFill>
+              </a:defRPr>
+            </a:pPr>
+            <a:r>
+              <a:t>• Demo: same question, 3 tools, 3 jobs.</a:t>
+            </a:r>
+          </a:p>
+          <a:p>
+            <a:pPr lvl="1">
+              <a:defRPr sz="1300">
+                <a:solidFill>
+                  <a:srgbClr val="546E7A"/>
+                </a:solidFill>
+              </a:defRPr>
+            </a:pPr>
+            <a:r>
+              <a:t>• Student free first; 3 golden rules everywhere.</a:t>
+            </a:r>
+          </a:p>
+          <a:p>
+            <a:pPr lvl="1">
+              <a:defRPr sz="1300">
+                <a:solidFill>
+                  <a:srgbClr val="546E7A"/>
+                </a:solidFill>
+              </a:defRPr>
+            </a:pPr>
+            <a:r>
+              <a:t>• AI Tools page bookmarked: the pocket pharmacy.</a:t>
+            </a:r>
+          </a:p>
+        </p:txBody>
+      </p:sp>
+    </p:spTree>
+  </p:cSld>
+  <p:clrMapOvr>
+    <a:masterClrMapping/>
+  </p:clrMapOvr>
+</p:sld>
+</file>
+
+<file path=ppt/slides/slide15.xml><?xml version="1.0" encoding="utf-8"?>
 <p:sld xmlns:a="http://schemas.openxmlformats.org/drawingml/2006/main" xmlns:p="http://schemas.openxmlformats.org/presentationml/2006/main" xmlns:r="http://schemas.openxmlformats.org/officeDocument/2006/relationships">
   <p:cSld>
     <p:bg>
@@ -3356,7 +3940,7 @@
         </p:nvSpPr>
         <p:spPr>
           <a:xfrm>
-            <a:off x="822960" y="2011680"/>
+            <a:off x="822960" y="1828800"/>
             <a:ext cx="10515600" cy="1828800"/>
           </a:xfrm>
           <a:prstGeom prst="rect">
@@ -3371,22 +3955,22 @@
           <a:lstStyle/>
           <a:p>
             <a:r>
-              <a:rPr sz="4400" b="1">
+              <a:rPr sz="4000" b="1">
                 <a:solidFill>
                   <a:srgbClr val="FFFFFF"/>
                 </a:solidFill>
               </a:rPr>
-              <a:t>Séance 02 — Panorama des outils d'IA pour l'enseignant</a:t>
-            </a:r>
-          </a:p>
-          <a:p>
-            <a:r>
-              <a:rPr sz="2200">
+              <a:t>Séance 02 — Panorama des 12+ outils d'IA pour l'étudiant</a:t>
+            </a:r>
+          </a:p>
+          <a:p>
+            <a:r>
+              <a:rPr sz="2000">
                 <a:solidFill>
                   <a:srgbClr val="ECEFF1"/>
                 </a:solidFill>
               </a:rPr>
-              <a:t>Overview of AI tools for the teacher</a:t>
+              <a:t>Overview of 12+ AI tools for students</a:t>
             </a:r>
           </a:p>
         </p:txBody>
@@ -3399,8 +3983,8 @@
         </p:nvSpPr>
         <p:spPr>
           <a:xfrm>
-            <a:off x="822960" y="4114800"/>
-            <a:ext cx="10515600" cy="1371600"/>
+            <a:off x="822960" y="4023360"/>
+            <a:ext cx="10515600" cy="1463040"/>
           </a:xfrm>
           <a:prstGeom prst="rect">
             <a:avLst/>
@@ -3414,13 +3998,14 @@
           <a:lstStyle/>
           <a:p>
             <a:r>
-              <a:rPr sz="1600">
+              <a:rPr sz="1500">
                 <a:solidFill>
                   <a:srgbClr val="ECEFF1"/>
                 </a:solidFill>
               </a:rPr>
               <a:t>Module « Intelligence Artificielle » — 2ème année PEP · ENS
-Dr. Madani BELACEL — Université de Mostaganem</a:t>
+Dr. Madani BELACEL — Université de Mostaganem
+Prochaine séance : à venir.</a:t>
             </a:r>
           </a:p>
         </p:txBody>
@@ -3483,83 +4068,115 @@
           <a:lstStyle/>
           <a:p>
             <a:pPr>
-              <a:defRPr sz="2200"/>
-            </a:pPr>
-            <a:r>
-              <a:t>Citer et décrire 5 familles d'outils d'IA utiles à l'enseignant.</a:t>
-            </a:r>
-          </a:p>
-          <a:p>
-            <a:pPr>
-              <a:defRPr sz="2200"/>
-            </a:pPr>
-            <a:r>
-              <a:t>Pour une tâche donnée (préparer une leçon, illustrer, évaluer), choisir la famille et l'outil adapté.</a:t>
-            </a:r>
-          </a:p>
-          <a:p>
-            <a:pPr>
-              <a:defRPr sz="2200"/>
-            </a:pPr>
-            <a:r>
-              <a:t>Construire un tableau comparatif de 3 outils sur des critères précis (coût, facilité, RGPD, langue).</a:t>
-            </a:r>
-          </a:p>
-          <a:p>
-            <a:pPr>
-              <a:defRPr sz="2200"/>
-            </a:pPr>
-            <a:r>
-              <a:t>Identifier les précautions de base avant d'utiliser un outil avec des élèves (âge, données personnelles).</a:t>
+              <a:defRPr sz="2000"/>
+            </a:pPr>
+            <a:r>
+              <a:t>Classer les outils d'IA en 4 familles : comprendre, chercher, créer, organiser-coder.</a:t>
+            </a:r>
+          </a:p>
+          <a:p>
+            <a:pPr>
+              <a:defRPr sz="2000"/>
+            </a:pPr>
+            <a:r>
+              <a:t>Décrire en une phrase l'usage de chacun des 12 outils du module.</a:t>
+            </a:r>
+          </a:p>
+          <a:p>
+            <a:pPr>
+              <a:defRPr sz="2000"/>
+            </a:pPr>
+            <a:r>
+              <a:t>Comparer 3 outils en démonstration : assistant, moteur sourcé, création visuelle.</a:t>
+            </a:r>
+          </a:p>
+          <a:p>
+            <a:pPr>
+              <a:defRPr sz="2000"/>
+            </a:pPr>
+            <a:r>
+              <a:t>Choisir le bon outil pour une tâche avec l'arbre de décision.</a:t>
+            </a:r>
+          </a:p>
+          <a:p>
+            <a:pPr>
+              <a:defRPr sz="2000"/>
+            </a:pPr>
+            <a:r>
+              <a:t>Éviter les 3 erreurs de débutant : tout demander au même outil, croire sans vérifier, payer avant d'essayer le gratuit.</a:t>
             </a:r>
           </a:p>
           <a:p/>
           <a:p>
+            <a:pPr>
+              <a:defRPr sz="1300" i="1">
+                <a:solidFill>
+                  <a:srgbClr val="78899C"/>
+                </a:solidFill>
+              </a:defRPr>
+            </a:pPr>
+            <a:r>
+              <a:t>English summary:</a:t>
+            </a:r>
+          </a:p>
+          <a:p>
             <a:pPr lvl="1">
-              <a:defRPr sz="1400">
+              <a:defRPr sz="1300">
                 <a:solidFill>
                   <a:srgbClr val="546E7A"/>
                 </a:solidFill>
               </a:defRPr>
             </a:pPr>
             <a:r>
-              <a:t>• Name and describe 5 families of AI tools useful to the teacher.</a:t>
+              <a:t>• Sort AI tools into 4 families: understand, search, create, organise-code.</a:t>
             </a:r>
           </a:p>
           <a:p>
             <a:pPr lvl="1">
-              <a:defRPr sz="1400">
+              <a:defRPr sz="1300">
                 <a:solidFill>
                   <a:srgbClr val="546E7A"/>
                 </a:solidFill>
               </a:defRPr>
             </a:pPr>
             <a:r>
-              <a:t>• For a given task (preparing a lesson, illustrating, assessing), choose the right family and tool.</a:t>
+              <a:t>• Describe in one sentence the use of each of the module's 12 tools.</a:t>
             </a:r>
           </a:p>
           <a:p>
             <a:pPr lvl="1">
-              <a:defRPr sz="1400">
+              <a:defRPr sz="1300">
                 <a:solidFill>
                   <a:srgbClr val="546E7A"/>
                 </a:solidFill>
               </a:defRPr>
             </a:pPr>
             <a:r>
-              <a:t>• Build a comparison table of 3 tools using precise criteria (cost, ease, GDPR, language).</a:t>
+              <a:t>• Compare 3 tools in a demo: assistant, sourced engine, visual creation.</a:t>
             </a:r>
           </a:p>
           <a:p>
             <a:pPr lvl="1">
-              <a:defRPr sz="1400">
+              <a:defRPr sz="1300">
                 <a:solidFill>
                   <a:srgbClr val="546E7A"/>
                 </a:solidFill>
               </a:defRPr>
             </a:pPr>
             <a:r>
-              <a:t>• Identify basic precautions before using a tool with pupils (age, personal data).</a:t>
+              <a:t>• Pick the right tool for a task with the decision tree.</a:t>
+            </a:r>
+          </a:p>
+          <a:p>
+            <a:pPr lvl="1">
+              <a:defRPr sz="1300">
+                <a:solidFill>
+                  <a:srgbClr val="546E7A"/>
+                </a:solidFill>
+              </a:defRPr>
+            </a:pPr>
+            <a:r>
+              <a:t>• Avoid 3 beginner mistakes: asking everything to one tool, believing without checking, paying before trying free.</a:t>
             </a:r>
           </a:p>
         </p:txBody>
@@ -3598,7 +4215,7 @@
           <a:lstStyle/>
           <a:p>
             <a:r>
-              <a:t>Déroulé (1 h 30)</a:t>
+              <a:t>Déroulé pédagogique (1 h 30)</a:t>
             </a:r>
             <a:r>
               <a:t>  ·  Session plan</a:t>
@@ -3622,123 +4239,135 @@
           <a:lstStyle/>
           <a:p>
             <a:pPr>
-              <a:defRPr sz="2200"/>
-            </a:pPr>
-            <a:r>
-              <a:t>00–10 — Accueil, rappel et sondage</a:t>
-            </a:r>
-          </a:p>
-          <a:p>
-            <a:pPr>
-              <a:defRPr sz="2200"/>
-            </a:pPr>
-            <a:r>
-              <a:t>10–30 — Les 6 familles d'outils</a:t>
-            </a:r>
-          </a:p>
-          <a:p>
-            <a:pPr>
-              <a:defRPr sz="2200"/>
-            </a:pPr>
-            <a:r>
-              <a:t>30–55 — Démo guidée de 3 outils</a:t>
-            </a:r>
-          </a:p>
-          <a:p>
-            <a:pPr>
-              <a:defRPr sz="2200"/>
-            </a:pPr>
-            <a:r>
-              <a:t>55–70 — Critères de choix d'un outil</a:t>
-            </a:r>
-          </a:p>
-          <a:p>
-            <a:pPr>
-              <a:defRPr sz="2200"/>
-            </a:pPr>
-            <a:r>
-              <a:t>70–80 — Activité : tableau comparatif</a:t>
-            </a:r>
-          </a:p>
-          <a:p>
-            <a:pPr>
-              <a:defRPr sz="2200"/>
-            </a:pPr>
-            <a:r>
-              <a:t>80–90 — Synthèse et annonce séance 3</a:t>
+              <a:defRPr sz="2000"/>
+            </a:pPr>
+            <a:r>
+              <a:t>00–05 — Accroche : la jungle des 12 noms</a:t>
+            </a:r>
+          </a:p>
+          <a:p>
+            <a:pPr>
+              <a:defRPr sz="2000"/>
+            </a:pPr>
+            <a:r>
+              <a:t>05–25 — Explication : les 4 familles</a:t>
+            </a:r>
+          </a:p>
+          <a:p>
+            <a:pPr>
+              <a:defRPr sz="2000"/>
+            </a:pPr>
+            <a:r>
+              <a:t>25–50 — Démo : 3 outils en action</a:t>
+            </a:r>
+          </a:p>
+          <a:p>
+            <a:pPr>
+              <a:defRPr sz="2000"/>
+            </a:pPr>
+            <a:r>
+              <a:t>50–70 — Exercice guidé : le bon pharmacien</a:t>
+            </a:r>
+          </a:p>
+          <a:p>
+            <a:pPr>
+              <a:defRPr sz="2000"/>
+            </a:pPr>
+            <a:r>
+              <a:t>70–80 — Démo 2 : mauvais vs bon prompt</a:t>
+            </a:r>
+          </a:p>
+          <a:p>
+            <a:pPr>
+              <a:defRPr sz="2000"/>
+            </a:pPr>
+            <a:r>
+              <a:t>80–90 — Synthèse, quiz et annonce de la séance 3</a:t>
             </a:r>
           </a:p>
           <a:p/>
           <a:p>
+            <a:pPr>
+              <a:defRPr sz="1300" i="1">
+                <a:solidFill>
+                  <a:srgbClr val="78899C"/>
+                </a:solidFill>
+              </a:defRPr>
+            </a:pPr>
+            <a:r>
+              <a:t>English summary:</a:t>
+            </a:r>
+          </a:p>
+          <a:p>
             <a:pPr lvl="1">
-              <a:defRPr sz="1400">
+              <a:defRPr sz="1300">
                 <a:solidFill>
                   <a:srgbClr val="546E7A"/>
                 </a:solidFill>
               </a:defRPr>
             </a:pPr>
             <a:r>
-              <a:t>• Welcome, recap and survey</a:t>
+              <a:t>• Hook: the 12-name jungle</a:t>
             </a:r>
           </a:p>
           <a:p>
             <a:pPr lvl="1">
-              <a:defRPr sz="1400">
+              <a:defRPr sz="1300">
                 <a:solidFill>
                   <a:srgbClr val="546E7A"/>
                 </a:solidFill>
               </a:defRPr>
             </a:pPr>
             <a:r>
-              <a:t>• The 6 tool families</a:t>
+              <a:t>• Explanation: the 4 families</a:t>
             </a:r>
           </a:p>
           <a:p>
             <a:pPr lvl="1">
-              <a:defRPr sz="1400">
+              <a:defRPr sz="1300">
                 <a:solidFill>
                   <a:srgbClr val="546E7A"/>
                 </a:solidFill>
               </a:defRPr>
             </a:pPr>
             <a:r>
-              <a:t>• Guided demo of 3 tools</a:t>
+              <a:t>• Demo: 3 tools in action</a:t>
             </a:r>
           </a:p>
           <a:p>
             <a:pPr lvl="1">
-              <a:defRPr sz="1400">
+              <a:defRPr sz="1300">
                 <a:solidFill>
                   <a:srgbClr val="546E7A"/>
                 </a:solidFill>
               </a:defRPr>
             </a:pPr>
             <a:r>
-              <a:t>• Choosing criteria for a tool</a:t>
+              <a:t>• Guided exercise: the good pharmacist</a:t>
             </a:r>
           </a:p>
           <a:p>
             <a:pPr lvl="1">
-              <a:defRPr sz="1400">
+              <a:defRPr sz="1300">
                 <a:solidFill>
                   <a:srgbClr val="546E7A"/>
                 </a:solidFill>
               </a:defRPr>
             </a:pPr>
             <a:r>
-              <a:t>• Activity: comparison table</a:t>
+              <a:t>• Demo 2: bad vs good prompt</a:t>
             </a:r>
           </a:p>
           <a:p>
             <a:pPr lvl="1">
-              <a:defRPr sz="1400">
+              <a:defRPr sz="1300">
                 <a:solidFill>
                   <a:srgbClr val="546E7A"/>
                 </a:solidFill>
               </a:defRPr>
             </a:pPr>
             <a:r>
-              <a:t>• Wrap-up and preview of session 3</a:t>
+              <a:t>• Wrap-up, quiz and preview of session 3</a:t>
             </a:r>
           </a:p>
         </p:txBody>
@@ -3777,10 +4406,10 @@
           <a:lstStyle/>
           <a:p>
             <a:r>
-              <a:t>Les 6 familles d'outils d'IA</a:t>
-            </a:r>
-            <a:r>
-              <a:t>  ·  The 6 families of AI tools</a:t>
+              <a:t>🎬 Accroche (5 min)</a:t>
+            </a:r>
+            <a:r>
+              <a:t>  ·  Hook</a:t>
             </a:r>
           </a:p>
         </p:txBody>
@@ -3801,23 +4430,51 @@
           <a:lstStyle/>
           <a:p>
             <a:pPr>
-              <a:defRPr sz="2200"/>
-            </a:pPr>
-            <a:r>
-              <a:t>Pour se repérer, on classe les outils d'IA en six grandes familles selon ce qu'ils produisent. Un même site peut cumuler plusieurs familles.</a:t>
+              <a:defRPr sz="2000"/>
+            </a:pPr>
+            <a:r>
+              <a:t>❓ ChatGPT, Gemini, Perplexity, Canva, Notion… 12 noms sur le tableau : qui peut dire à quoi sert chacun ? Aujourd'hui, on range cette jungle.</a:t>
+            </a:r>
+          </a:p>
+          <a:p>
+            <a:pPr>
+              <a:defRPr sz="2000"/>
+            </a:pPr>
+            <a:r>
+              <a:t>🍳 🍳 Les outils d'IA, c'est comme la pharmacie : on ne soigne pas tout avec le même sirop. Le pharmacien (vous, bientôt) lit l'ordonnance (la tâche) puis choisit le bon flacon.</a:t>
+            </a:r>
+          </a:p>
+          <a:p>
+            <a:pPr>
+              <a:defRPr sz="2000"/>
+            </a:pPr>
+            <a:r>
+              <a:t>💡 💡 12 outils, 4 familles : COMPRENDRE (assistants), CHERCHER (moteurs sourcés), CRÉER (slides, images, voix), ORGANISER-CODER (notes, code, local).</a:t>
             </a:r>
           </a:p>
           <a:p/>
           <a:p>
+            <a:pPr>
+              <a:defRPr sz="1300" i="1">
+                <a:solidFill>
+                  <a:srgbClr val="78899C"/>
+                </a:solidFill>
+              </a:defRPr>
+            </a:pPr>
+            <a:r>
+              <a:t>English summary:</a:t>
+            </a:r>
+          </a:p>
+          <a:p>
             <a:pPr lvl="1">
-              <a:defRPr sz="1400">
+              <a:defRPr sz="1300">
                 <a:solidFill>
                   <a:srgbClr val="546E7A"/>
                 </a:solidFill>
               </a:defRPr>
             </a:pPr>
             <a:r>
-              <a:t>• To get oriented, we classify AI tools into six main families according to what they produce. One site can combine several families.</a:t>
+              <a:t>• 💡 12 tools, 4 families: UNDERSTAND (assistants), SEARCH (sourced engines), CREATE (slides, images, voice), ORGANISE-CODE (notes, code, local).</a:t>
             </a:r>
           </a:p>
         </p:txBody>
@@ -3856,10 +4513,10 @@
           <a:lstStyle/>
           <a:p>
             <a:r>
-              <a:t>Zoom sur les assistants de texte</a:t>
-            </a:r>
-            <a:r>
-              <a:t>  ·  Focus on text assistants</a:t>
+              <a:t>Les 4 familles : rangez la jungle</a:t>
+            </a:r>
+            <a:r>
+              <a:t>  ·  The 4 families: tidy the jungle</a:t>
             </a:r>
           </a:p>
         </p:txBody>
@@ -3880,83 +4537,35 @@
           <a:lstStyle/>
           <a:p>
             <a:pPr>
-              <a:defRPr sz="2200"/>
-            </a:pPr>
-            <a:r>
-              <a:t>Ce sont les outils les plus utilisés : ils peuvent rédiger, résumer, reformuler, traduire, proposer des exercices. Pour un enseignant, ils font gagner beaucoup de temps sur la préparation.</a:t>
-            </a:r>
-          </a:p>
-          <a:p>
-            <a:pPr>
-              <a:defRPr sz="2200"/>
-            </a:pPr>
-            <a:r>
-              <a:t>&lt;strong&gt;Usages concrets :&lt;/strong&gt; rédiger la consigne d'un exercice, adapter un texte à un niveau de lecture, créer une dictée, reformuler une explication simple.</a:t>
-            </a:r>
-          </a:p>
-          <a:p>
-            <a:pPr>
-              <a:defRPr sz="2200"/>
-            </a:pPr>
-            <a:r>
-              <a:t>&lt;strong&gt;Point de vigilance :&lt;/strong&gt; toujours relire et vérifier le contenu (niveau de langue, exactitude des faits, vocabulaire adapté à l'âge).</a:t>
-            </a:r>
-          </a:p>
-          <a:p>
-            <a:pPr>
-              <a:defRPr sz="2200"/>
-            </a:pPr>
-            <a:r>
-              <a:t>&lt;strong&gt;Exemples :&lt;/strong&gt; ChatGPT, Gemini, Claude, Le Chat (Mistral), Copilot.</a:t>
+              <a:defRPr sz="2000"/>
+            </a:pPr>
+            <a:r>
+              <a:t>Retenez 4 tiroirs, pas 12 noms. Devant chaque tâche, demandez-vous : est-ce que je veux COMPRENDRE, CHERCHER, CRÉER ou ORGANISER-CODER ? Le tiroir désigne l'outil.</a:t>
             </a:r>
           </a:p>
           <a:p/>
           <a:p>
+            <a:pPr>
+              <a:defRPr sz="1300" i="1">
+                <a:solidFill>
+                  <a:srgbClr val="78899C"/>
+                </a:solidFill>
+              </a:defRPr>
+            </a:pPr>
+            <a:r>
+              <a:t>English summary:</a:t>
+            </a:r>
+          </a:p>
+          <a:p>
             <a:pPr lvl="1">
-              <a:defRPr sz="1400">
+              <a:defRPr sz="1300">
                 <a:solidFill>
                   <a:srgbClr val="546E7A"/>
                 </a:solidFill>
               </a:defRPr>
             </a:pPr>
             <a:r>
-              <a:t>• These are the most used tools: they can write, summarise, rephrase, translate, propose exercises. For a teacher, they save a lot of preparation time.</a:t>
-            </a:r>
-          </a:p>
-          <a:p>
-            <a:pPr lvl="1">
-              <a:defRPr sz="1400">
-                <a:solidFill>
-                  <a:srgbClr val="546E7A"/>
-                </a:solidFill>
-              </a:defRPr>
-            </a:pPr>
-            <a:r>
-              <a:t>• &lt;strong&gt;Concrete uses:&lt;/strong&gt; write exercise instructions, adapt a text to a reading level, create a dictation, rephrase a simple explanation.</a:t>
-            </a:r>
-          </a:p>
-          <a:p>
-            <a:pPr lvl="1">
-              <a:defRPr sz="1400">
-                <a:solidFill>
-                  <a:srgbClr val="546E7A"/>
-                </a:solidFill>
-              </a:defRPr>
-            </a:pPr>
-            <a:r>
-              <a:t>• &lt;strong&gt;Watch out:&lt;/strong&gt; always proofread and check the content (language level, factual accuracy, age-appropriate vocabulary).</a:t>
-            </a:r>
-          </a:p>
-          <a:p>
-            <a:pPr lvl="1">
-              <a:defRPr sz="1400">
-                <a:solidFill>
-                  <a:srgbClr val="546E7A"/>
-                </a:solidFill>
-              </a:defRPr>
-            </a:pPr>
-            <a:r>
-              <a:t>• &lt;strong&gt;Examples:&lt;/strong&gt; ChatGPT, Gemini, Claude, Le Chat (Mistral), Copilot.</a:t>
+              <a:t>• Remember 4 drawers, not 12 names. Before each task, ask: do I want to UNDERSTAND, SEARCH, CREATE or ORGANISE-CODE? The drawer points to the tool.</a:t>
             </a:r>
           </a:p>
         </p:txBody>
@@ -3995,10 +4604,10 @@
           <a:lstStyle/>
           <a:p>
             <a:r>
-              <a:t>Zoom sur les générateurs d'images</a:t>
-            </a:r>
-            <a:r>
-              <a:t>  ·  Focus on image generators</a:t>
+              <a:t>Les 12 outils en fiches express</a:t>
+            </a:r>
+            <a:r>
+              <a:t>  ·  The 12 tools in flash sheets</a:t>
             </a:r>
           </a:p>
         </p:txBody>
@@ -4019,83 +4628,111 @@
           <a:lstStyle/>
           <a:p>
             <a:pPr>
-              <a:defRPr sz="2200"/>
-            </a:pPr>
-            <a:r>
-              <a:t>Un générateur d'images transforme une description en texte en une illustration. Utile pour illustrer une leçon, créer un poster, un coloriage ou un personnage de classe.</a:t>
-            </a:r>
-          </a:p>
-          <a:p>
-            <a:pPr>
-              <a:defRPr sz="2200"/>
-            </a:pPr>
-            <a:r>
-              <a:t>&lt;strong&gt;Consigne de description :&lt;/strong&gt; sujet, style (aquarelle, bande dessinée, photo), ambiance (lumineux), et ce qu'il ne faut PAS représenter.</a:t>
-            </a:r>
-          </a:p>
-          <a:p>
-            <a:pPr>
-              <a:defRPr sz="2200"/>
-            </a:pPr>
-            <a:r>
-              <a:t>&lt;strong&gt;Exemples :&lt;/strong&gt; DALL·E (dans ChatGPT/Bing), Midjourney, Leonardo, Ideogram, et l'outil « Magic Media » de Canva.</a:t>
-            </a:r>
-          </a:p>
-          <a:p>
-            <a:pPr>
-              <a:defRPr sz="2200"/>
-            </a:pPr>
-            <a:r>
-              <a:t>&lt;strong&gt;Précautions :&lt;/strong&gt; vérifier le réalisme (déformations), respecter les droits d'auteur, ne pas figurer de vrai enfant identifiable.</a:t>
+              <a:defRPr sz="2000"/>
+            </a:pPr>
+            <a:r>
+              <a:t>Une phrase par outil, à connaître par cœur. Le détail complet (étapes, forces, limites) est sur la page « Outils IA » du module : chaque outil y a sa fiche.</a:t>
+            </a:r>
+          </a:p>
+          <a:p>
+            <a:pPr>
+              <a:defRPr sz="2000"/>
+            </a:pPr>
+            <a:r>
+              <a:t>&lt;strong&gt;ChatGPT :&lt;/strong&gt; l'assistant généraliste qui explique, résume et rédige.</a:t>
+            </a:r>
+          </a:p>
+          <a:p>
+            <a:pPr>
+              <a:defRPr sz="2000"/>
+            </a:pPr>
+            <a:r>
+              <a:t>&lt;strong&gt;Gemini :&lt;/strong&gt; comme ChatGPT + lit images et PDF.</a:t>
+            </a:r>
+          </a:p>
+          <a:p>
+            <a:pPr>
+              <a:defRPr sz="2000"/>
+            </a:pPr>
+            <a:r>
+              <a:t>&lt;strong&gt;Claude :&lt;/strong&gt; le champion des longs textes en bon français.</a:t>
+            </a:r>
+          </a:p>
+          <a:p>
+            <a:pPr>
+              <a:defRPr sz="2000"/>
+            </a:pPr>
+            <a:r>
+              <a:t>&lt;strong&gt;Perplexity :&lt;/strong&gt; répond AVEC les sources à ouvrir.</a:t>
+            </a:r>
+          </a:p>
+          <a:p>
+            <a:pPr>
+              <a:defRPr sz="2000"/>
+            </a:pPr>
+            <a:r>
+              <a:t>&lt;strong&gt;Scholar / Consensus :&lt;/strong&gt; la bibliothèque scientifique (articles, consensus).</a:t>
             </a:r>
           </a:p>
           <a:p/>
           <a:p>
+            <a:pPr>
+              <a:defRPr sz="1300" i="1">
+                <a:solidFill>
+                  <a:srgbClr val="78899C"/>
+                </a:solidFill>
+              </a:defRPr>
+            </a:pPr>
+            <a:r>
+              <a:t>English summary:</a:t>
+            </a:r>
+          </a:p>
+          <a:p>
             <a:pPr lvl="1">
-              <a:defRPr sz="1400">
+              <a:defRPr sz="1300">
                 <a:solidFill>
                   <a:srgbClr val="546E7A"/>
                 </a:solidFill>
               </a:defRPr>
             </a:pPr>
             <a:r>
-              <a:t>• An image generator turns a text description into an illustration. Useful to illustrate a lesson, create a poster, a colouring sheet or a class mascot.</a:t>
+              <a:t>• One sentence per tool, to know by heart. Full detail (steps, strengths, limits) is on the module's "AI Tools" page: each tool has its sheet there.</a:t>
             </a:r>
           </a:p>
           <a:p>
             <a:pPr lvl="1">
-              <a:defRPr sz="1400">
+              <a:defRPr sz="1300">
                 <a:solidFill>
                   <a:srgbClr val="546E7A"/>
                 </a:solidFill>
               </a:defRPr>
             </a:pPr>
             <a:r>
-              <a:t>• &lt;strong&gt;Description prompt:&lt;/strong&gt; subject, style (watercolour, comic, photo), mood (bright), and what should NOT be depicted.</a:t>
+              <a:t>• &lt;strong&gt;ChatGPT:&lt;/strong&gt; the generalist assistant explaining, summarising, writing.</a:t>
             </a:r>
           </a:p>
           <a:p>
             <a:pPr lvl="1">
-              <a:defRPr sz="1400">
+              <a:defRPr sz="1300">
                 <a:solidFill>
                   <a:srgbClr val="546E7A"/>
                 </a:solidFill>
               </a:defRPr>
             </a:pPr>
             <a:r>
-              <a:t>• &lt;strong&gt;Examples:&lt;/strong&gt; DALL·E (in ChatGPT/Bing), Midjourney, Leonardo, Ideogram, and Canva's "Magic Media" tool.</a:t>
+              <a:t>• &lt;strong&gt;Gemini:&lt;/strong&gt; like ChatGPT + reads images and PDFs.</a:t>
             </a:r>
           </a:p>
           <a:p>
             <a:pPr lvl="1">
-              <a:defRPr sz="1400">
+              <a:defRPr sz="1300">
                 <a:solidFill>
                   <a:srgbClr val="546E7A"/>
                 </a:solidFill>
               </a:defRPr>
             </a:pPr>
             <a:r>
-              <a:t>• &lt;strong&gt;Precautions:&lt;/strong&gt; check realism (deformations), respect copyright, never depict an identifiable real child.</a:t>
+              <a:t>• &lt;strong&gt;Claude:&lt;/strong&gt; the champion of long texts in good French.</a:t>
             </a:r>
           </a:p>
         </p:txBody>
@@ -4134,10 +4771,10 @@
           <a:lstStyle/>
           <a:p>
             <a:r>
-              <a:t>Zoom sur les outils de quiz, de voix et de présentation</a:t>
-            </a:r>
-            <a:r>
-              <a:t>  ·  Focus on quiz, voice and presentation tools</a:t>
+              <a:t>Démo : la même question à 3 outils</a:t>
+            </a:r>
+            <a:r>
+              <a:t>  ·  Demo: the same question to 3 tools</a:t>
             </a:r>
           </a:p>
         </p:txBody>
@@ -4158,83 +4795,103 @@
           <a:lstStyle/>
           <a:p>
             <a:pPr>
-              <a:defRPr sz="2200"/>
-            </a:pPr>
-            <a:r>
-              <a:t>Ces outils se concentrent sur des tâches très précises, souvent avec des versions gratuites suffisantes pour une classe.</a:t>
-            </a:r>
-          </a:p>
-          <a:p>
-            <a:pPr>
-              <a:defRPr sz="2200"/>
-            </a:pPr>
-            <a:r>
-              <a:t>&lt;strong&gt;Quiz / évaluation :&lt;/strong&gt; Quizizz AI, Kahoot, LearningApps, Socrative — générer un QCM à partir d'une consigne, avec correction automatique.</a:t>
-            </a:r>
-          </a:p>
-          <a:p>
-            <a:pPr>
-              <a:defRPr sz="2200"/>
-            </a:pPr>
-            <a:r>
-              <a:t>&lt;strong&gt;Voix / audio :&lt;/strong&gt; synthèse vocale pour lire un texte à voix haute (aide à la lecture), génération de dictées audio.</a:t>
-            </a:r>
-          </a:p>
-          <a:p>
-            <a:pPr>
-              <a:defRPr sz="2200"/>
-            </a:pPr>
-            <a:r>
-              <a:t>&lt;strong&gt;Présentation :&lt;/strong&gt; Gamma, Canva, PowerPoint — créer des diapositives structurées à partir d'un plan.</a:t>
+              <a:defRPr sz="2000"/>
+            </a:pPr>
+            <a:r>
+              <a:t>Question test : « Explique la différenciation pédagogique avec un exemple de primaire. » Regardez ce que CHAQUE outil apporte — aucun ne fait tout.</a:t>
+            </a:r>
+          </a:p>
+          <a:p>
+            <a:pPr>
+              <a:defRPr sz="2000"/>
+            </a:pPr>
+            <a:r>
+              <a:t>&lt;strong&gt;ChatGPT (🔵) :&lt;/strong&gt; explication claire + exemple, sans sources. Parfait pour COMPRENDRE vite.</a:t>
+            </a:r>
+          </a:p>
+          <a:p>
+            <a:pPr>
+              <a:defRPr sz="2000"/>
+            </a:pPr>
+            <a:r>
+              <a:t>&lt;strong&gt;Perplexity (🟢) :&lt;/strong&gt; réponse plus courte MAIS avec 3 liens : parfait pour VÉRIFIER et citer.</a:t>
+            </a:r>
+          </a:p>
+          <a:p>
+            <a:pPr>
+              <a:defRPr sz="2000"/>
+            </a:pPr>
+            <a:r>
+              <a:t>&lt;strong&gt;Canva IA (🟠) :&lt;/strong&gt; une affiche « différenciation » pour la classe : parfait pour MONTRER.</a:t>
+            </a:r>
+          </a:p>
+          <a:p>
+            <a:pPr>
+              <a:defRPr sz="2000"/>
+            </a:pPr>
+            <a:r>
+              <a:t>&lt;strong&gt;Leçon :&lt;/strong&gt; comprendre → bleu ; prouver → vert ; montrer → orange. Trois outils, trois métiers.</a:t>
             </a:r>
           </a:p>
           <a:p/>
           <a:p>
+            <a:pPr>
+              <a:defRPr sz="1300" i="1">
+                <a:solidFill>
+                  <a:srgbClr val="78899C"/>
+                </a:solidFill>
+              </a:defRPr>
+            </a:pPr>
+            <a:r>
+              <a:t>English summary:</a:t>
+            </a:r>
+          </a:p>
+          <a:p>
             <a:pPr lvl="1">
-              <a:defRPr sz="1400">
+              <a:defRPr sz="1300">
                 <a:solidFill>
                   <a:srgbClr val="546E7A"/>
                 </a:solidFill>
               </a:defRPr>
             </a:pPr>
             <a:r>
-              <a:t>• These tools focus on very specific tasks, often with free versions that are enough for a classroom.</a:t>
+              <a:t>• Test question: "Explain pedagogical differentiation with a primary example." Watch what EACH tool brings — none does everything.</a:t>
             </a:r>
           </a:p>
           <a:p>
             <a:pPr lvl="1">
-              <a:defRPr sz="1400">
+              <a:defRPr sz="1300">
                 <a:solidFill>
                   <a:srgbClr val="546E7A"/>
                 </a:solidFill>
               </a:defRPr>
             </a:pPr>
             <a:r>
-              <a:t>• &lt;strong&gt;Quiz / assessment:&lt;/strong&gt; Quizizz AI, Kahoot, LearningApps, Socrative — generate a quiz from a prompt, with automatic marking.</a:t>
+              <a:t>• &lt;strong&gt;ChatGPT (🔵):&lt;/strong&gt; clear explanation + example, no sources. Perfect to UNDERSTAND fast.</a:t>
             </a:r>
           </a:p>
           <a:p>
             <a:pPr lvl="1">
-              <a:defRPr sz="1400">
+              <a:defRPr sz="1300">
                 <a:solidFill>
                   <a:srgbClr val="546E7A"/>
                 </a:solidFill>
               </a:defRPr>
             </a:pPr>
             <a:r>
-              <a:t>• &lt;strong&gt;Voice / audio:&lt;/strong&gt; speech synthesis to read a text aloud (reading support), generate audio dictations.</a:t>
+              <a:t>• &lt;strong&gt;Perplexity (🟢):&lt;/strong&gt; shorter answer BUT with 3 links: perfect to CHECK and cite.</a:t>
             </a:r>
           </a:p>
           <a:p>
             <a:pPr lvl="1">
-              <a:defRPr sz="1400">
+              <a:defRPr sz="1300">
                 <a:solidFill>
                   <a:srgbClr val="546E7A"/>
                 </a:solidFill>
               </a:defRPr>
             </a:pPr>
             <a:r>
-              <a:t>• &lt;strong&gt;Presentation:&lt;/strong&gt; Gamma, Canva, PowerPoint — build structured slides from an outline.</a:t>
+              <a:t>• &lt;strong&gt;Canva AI (🟠):&lt;/strong&gt; a "differentiation" poster for class: perfect to SHOW.</a:t>
             </a:r>
           </a:p>
         </p:txBody>
@@ -4273,10 +4930,10 @@
           <a:lstStyle/>
           <a:p>
             <a:r>
-              <a:t>Choisir le bon outil pour la bonne tâche</a:t>
-            </a:r>
-            <a:r>
-              <a:t>  ·  Choose the right tool for the right task</a:t>
+              <a:t>Bien choisir : l'arbre de décision du pharmacien</a:t>
+            </a:r>
+            <a:r>
+              <a:t>  ·  Choose well: the pharmacist's decision tree</a:t>
             </a:r>
           </a:p>
         </p:txBody>
@@ -4297,23 +4954,35 @@
           <a:lstStyle/>
           <a:p>
             <a:pPr>
-              <a:defRPr sz="2200"/>
-            </a:pPr>
-            <a:r>
-              <a:t>Voici une grille de décision en 5 questions à poser avant tout choix d'outil :</a:t>
+              <a:defRPr sz="2000"/>
+            </a:pPr>
+            <a:r>
+              <a:t>Trois questions suffisent pour ne plus jamais se tromper d'outil.</a:t>
             </a:r>
           </a:p>
           <a:p/>
           <a:p>
+            <a:pPr>
+              <a:defRPr sz="1300" i="1">
+                <a:solidFill>
+                  <a:srgbClr val="78899C"/>
+                </a:solidFill>
+              </a:defRPr>
+            </a:pPr>
+            <a:r>
+              <a:t>English summary:</a:t>
+            </a:r>
+          </a:p>
+          <a:p>
             <a:pPr lvl="1">
-              <a:defRPr sz="1400">
+              <a:defRPr sz="1300">
                 <a:solidFill>
                   <a:srgbClr val="546E7A"/>
                 </a:solidFill>
               </a:defRPr>
             </a:pPr>
             <a:r>
-              <a:t>• Here is a 5-question decision grid to ask before choosing any tool:</a:t>
+              <a:t>• Three questions are enough to never pick the wrong tool again.</a:t>
             </a:r>
           </a:p>
         </p:txBody>
@@ -4352,10 +5021,10 @@
           <a:lstStyle/>
           <a:p>
             <a:r>
-              <a:t>Un scénario complet : la leçon de sciences de la semaine</a:t>
-            </a:r>
-            <a:r>
-              <a:t>  ·  A complete scenario: the week's science lesson</a:t>
+              <a:t>Comment en profiter au maximum</a:t>
+            </a:r>
+            <a:r>
+              <a:t>  ·  How to get the most out of it</a:t>
             </a:r>
           </a:p>
         </p:txBody>
@@ -4376,23 +5045,103 @@
           <a:lstStyle/>
           <a:p>
             <a:pPr>
-              <a:defRPr sz="2200"/>
-            </a:pPr>
-            <a:r>
-              <a:t>Prenons un exemple : préparer une leçon de découverte du monde sur « le cycle de l'eau » pour des CP.</a:t>
+              <a:defRPr sz="2000"/>
+            </a:pPr>
+            <a:r>
+              <a:t>Le bon pharmacien ne connaît pas 12 sirops par cœur le premier jour : il connaît 4 tiroirs, 1 outil préféré par tiroir, et la page « Outils IA » pour le reste.</a:t>
+            </a:r>
+          </a:p>
+          <a:p>
+            <a:pPr>
+              <a:defRPr sz="2000"/>
+            </a:pPr>
+            <a:r>
+              <a:t>&lt;strong&gt;✅ 1 favori par tiroir :&lt;/strong&gt; choisissez vos 4 outils de tous les jours cette semaine.</a:t>
+            </a:r>
+          </a:p>
+          <a:p>
+            <a:pPr>
+              <a:defRPr sz="2000"/>
+            </a:pPr>
+            <a:r>
+              <a:t>&lt;strong&gt;✅ Gratuit d'abord :&lt;/strong&gt; comptes étudiants gratuits avant tout abonnement.</a:t>
+            </a:r>
+          </a:p>
+          <a:p>
+            <a:pPr>
+              <a:defRPr sz="2000"/>
+            </a:pPr>
+            <a:r>
+              <a:t>&lt;strong&gt;✅ Fiche outils :&lt;/strong&gt; gardez la page « Outils IA » en favori du navigateur.</a:t>
+            </a:r>
+          </a:p>
+          <a:p>
+            <a:pPr>
+              <a:defRPr sz="2000"/>
+            </a:pPr>
+            <a:r>
+              <a:t>&lt;strong&gt;✅ Testez à deux :&lt;/strong&gt; même question, deux outils, comparez — le meilleur exercice.</a:t>
             </a:r>
           </a:p>
           <a:p/>
           <a:p>
+            <a:pPr>
+              <a:defRPr sz="1300" i="1">
+                <a:solidFill>
+                  <a:srgbClr val="78899C"/>
+                </a:solidFill>
+              </a:defRPr>
+            </a:pPr>
+            <a:r>
+              <a:t>English summary:</a:t>
+            </a:r>
+          </a:p>
+          <a:p>
             <a:pPr lvl="1">
-              <a:defRPr sz="1400">
+              <a:defRPr sz="1300">
                 <a:solidFill>
                   <a:srgbClr val="546E7A"/>
                 </a:solidFill>
               </a:defRPr>
             </a:pPr>
             <a:r>
-              <a:t>• Let's take an example: preparing a "discovering the world" lesson on the water cycle for Year-1 pupils.</a:t>
+              <a:t>• The good pharmacist does not memorise 12 syrups on day one: he knows 4 drawers, 1 favourite tool per drawer, and the "AI Tools" page for the rest.</a:t>
+            </a:r>
+          </a:p>
+          <a:p>
+            <a:pPr lvl="1">
+              <a:defRPr sz="1300">
+                <a:solidFill>
+                  <a:srgbClr val="546E7A"/>
+                </a:solidFill>
+              </a:defRPr>
+            </a:pPr>
+            <a:r>
+              <a:t>• &lt;strong&gt;✅ 1 favourite per drawer:&lt;/strong&gt; pick your 4 everyday tools this week.</a:t>
+            </a:r>
+          </a:p>
+          <a:p>
+            <a:pPr lvl="1">
+              <a:defRPr sz="1300">
+                <a:solidFill>
+                  <a:srgbClr val="546E7A"/>
+                </a:solidFill>
+              </a:defRPr>
+            </a:pPr>
+            <a:r>
+              <a:t>• &lt;strong&gt;✅ Free first:&lt;/strong&gt; free student accounts before any subscription.</a:t>
+            </a:r>
+          </a:p>
+          <a:p>
+            <a:pPr lvl="1">
+              <a:defRPr sz="1300">
+                <a:solidFill>
+                  <a:srgbClr val="546E7A"/>
+                </a:solidFill>
+              </a:defRPr>
+            </a:pPr>
+            <a:r>
+              <a:t>• &lt;strong&gt;✅ Tools sheet:&lt;/strong&gt; bookmark the "AI Tools" page in your browser.</a:t>
             </a:r>
           </a:p>
         </p:txBody>

</xml_diff>

<commit_message>
feat(ia-pep-2): refonte S02 mode FAIRE
</commit_message>
<xml_diff>
--- a/ia-pep-2/seance-02/presentation.pptx
+++ b/ia-pep-2/seance-02/presentation.pptx
@@ -19,7 +19,6 @@
     <p:sldId id="267" r:id="rId18"/>
     <p:sldId id="268" r:id="rId19"/>
     <p:sldId id="269" r:id="rId20"/>
-    <p:sldId id="270" r:id="rId21"/>
   </p:sldIdLst>
   <p:sldSz cx="12191695" cy="6858000" type="screen4x3"/>
   <p:notesSz cx="6858000" cy="9144000"/>
@@ -3352,10 +3351,10 @@
           <a:lstStyle/>
           <a:p>
             <a:r>
-              <a:t>✏️ Exercice guidé (15 min)</a:t>
-            </a:r>
-            <a:r>
-              <a:t>  ·  Guided exercise</a:t>
+              <a:t>🧠 Fiche de synthèse — points clés</a:t>
+            </a:r>
+            <a:r>
+              <a:t>  ·  Summary sheet</a:t>
             </a:r>
           </a:p>
         </p:txBody>
@@ -3379,31 +3378,39 @@
               <a:defRPr sz="2000"/>
             </a:pPr>
             <a:r>
-              <a:t>8 situations d'étudiant : prescrivez le bon outil avec l'arbre de décision (sources ? créer ? organiser-coder ?). Justifiez en 1 phrase.</a:t>
-            </a:r>
-          </a:p>
-          <a:p>
-            <a:pPr>
-              <a:defRPr sz="2000"/>
-            </a:pPr>
-            <a:r>
-              <a:t>—</a:t>
-            </a:r>
-          </a:p>
-          <a:p>
-            <a:pPr>
-              <a:defRPr sz="2000"/>
-            </a:pPr>
-            <a:r>
-              <a:t>▶ Solution :</a:t>
-            </a:r>
-          </a:p>
-          <a:p>
-            <a:pPr>
-              <a:defRPr sz="2000"/>
-            </a:pPr>
-            <a:r>
-              <a:t>1) Expliquer une notion → 🔵 ChatGPT. 2) Citer 2 études → 🟢 Perplexity/Scholar. 3) Slides d'exposé → 🟠 Gamma. 4) Affiche → 🟠 Canva. 5) Planning révisions → 🟣 Notion. 6) Bug Python → 🟣 Copilot. 7) Résumer VOS PDF → 🟢 NotebookLM. 8) Chatbot sans code → 🟣 Dify.</a:t>
+              <a:t>J'ai ouvert Perplexity SANS compte et obtenu une réponse avec sources cliquables.</a:t>
+            </a:r>
+          </a:p>
+          <a:p>
+            <a:pPr>
+              <a:defRPr sz="2000"/>
+            </a:pPr>
+            <a:r>
+              <a:t>J'ai testé 1 question sur 2 outils et rempli mon tableau (fort + limite).</a:t>
+            </a:r>
+          </a:p>
+          <a:p>
+            <a:pPr>
+              <a:defRPr sz="2000"/>
+            </a:pPr>
+            <a:r>
+              <a:t>Je prescris avec l'arbre : sources ? créer ? organiser-coder ? sinon bleu.</a:t>
+            </a:r>
+          </a:p>
+          <a:p>
+            <a:pPr>
+              <a:defRPr sz="2000"/>
+            </a:pPr>
+            <a:r>
+              <a:t>J'ai mes 4 favoris (1 par tiroir), justifiés en 1 phrase chacun.</a:t>
+            </a:r>
+          </a:p>
+          <a:p>
+            <a:pPr>
+              <a:defRPr sz="2000"/>
+            </a:pPr>
+            <a:r>
+              <a:t>3 règles d'or partout : vérifier, citer, juger.</a:t>
             </a:r>
           </a:p>
           <a:p/>
@@ -3428,7 +3435,7 @@
               </a:defRPr>
             </a:pPr>
             <a:r>
-              <a:t>• 8 student situations: prescribe the right tool with the decision tree (sources? create? organise-code?). Justify in 1 sentence.</a:t>
+              <a:t>• I opened Perplexity with NO account and got an answer with clickable sources.</a:t>
             </a:r>
           </a:p>
           <a:p>
@@ -3440,7 +3447,19 @@
               </a:defRPr>
             </a:pPr>
             <a:r>
-              <a:t>• 1) Explain a notion → 🔵 ChatGPT. 2) Cite 2 studies → 🟢 Perplexity/Scholar. 3) Talk slides → 🟠 Gamma. 4) Poster → 🟠 Canva. 5) Revision plan → 🟣 Notion. 6) Python bug → 🟣 Copilot. 7) Summarise YOUR PDFs → 🟢 NotebookLM. 8) No-code chatbot → 🟣 Dify.</a:t>
+              <a:t>• I tested 1 question on 2 tools and filled my table (strength + limit).</a:t>
+            </a:r>
+          </a:p>
+          <a:p>
+            <a:pPr lvl="1">
+              <a:defRPr sz="1300">
+                <a:solidFill>
+                  <a:srgbClr val="546E7A"/>
+                </a:solidFill>
+              </a:defRPr>
+            </a:pPr>
+            <a:r>
+              <a:t>• I prescribe with the tree: sources? create? organise-code? else blue.</a:t>
             </a:r>
           </a:p>
         </p:txBody>
@@ -3479,10 +3498,10 @@
           <a:lstStyle/>
           <a:p>
             <a:r>
-              <a:t>🧠 Fiche de synthèse — points clés</a:t>
-            </a:r>
-            <a:r>
-              <a:t>  ·  Summary sheet</a:t>
+              <a:t>🧠 Quiz éclair (3 questions)</a:t>
+            </a:r>
+            <a:r>
+              <a:t>  ·  Quick quiz</a:t>
             </a:r>
           </a:p>
         </p:txBody>
@@ -3506,39 +3525,35 @@
               <a:defRPr sz="2000"/>
             </a:pPr>
             <a:r>
-              <a:t>4 tiroirs : 🔵 comprendre, 🟢 chercher, 🟠 créer, 🟣 organiser-coder.</a:t>
-            </a:r>
-          </a:p>
-          <a:p>
-            <a:pPr>
-              <a:defRPr sz="2000"/>
-            </a:pPr>
-            <a:r>
-              <a:t>Arbre : sources ? → créer ? → organiser-coder ? → sinon bleu.</a:t>
-            </a:r>
-          </a:p>
-          <a:p>
-            <a:pPr>
-              <a:defRPr sz="2000"/>
-            </a:pPr>
-            <a:r>
-              <a:t>1 favori par tiroir + page Outils IA en favori.</a:t>
-            </a:r>
-          </a:p>
-          <a:p>
-            <a:pPr>
-              <a:defRPr sz="2000"/>
-            </a:pPr>
-            <a:r>
-              <a:t>Gratuit étudiant d'abord, jamais d'abonnement aveugle.</a:t>
-            </a:r>
-          </a:p>
-          <a:p>
-            <a:pPr>
-              <a:defRPr sz="2000"/>
-            </a:pPr>
-            <a:r>
-              <a:t>3 règles d'or partout : vérifier, citer, juger.</a:t>
+              <a:t>Q1. Besoin de SOURCES : quel tiroir ?</a:t>
+            </a:r>
+            <a:br/>
+            <a:r>
+              <a:t>   ✅ 🟢 Vert (Perplexity, Scholar)</a:t>
+            </a:r>
+          </a:p>
+          <a:p>
+            <a:pPr>
+              <a:defRPr sz="2000"/>
+            </a:pPr>
+            <a:r>
+              <a:t>Q2. Slides d'exposé : quel outil ?</a:t>
+            </a:r>
+            <a:br/>
+            <a:r>
+              <a:t>   ✅ Gamma (créer à montrer)</a:t>
+            </a:r>
+          </a:p>
+          <a:p>
+            <a:pPr>
+              <a:defRPr sz="2000"/>
+            </a:pPr>
+            <a:r>
+              <a:t>Q3. Interroger VOS propres PDF : quel outil ?</a:t>
+            </a:r>
+            <a:br/>
+            <a:r>
+              <a:t>   ✅ NotebookLM (vert : chercher dans vos documents)</a:t>
             </a:r>
           </a:p>
           <a:p/>
@@ -3563,7 +3578,7 @@
               </a:defRPr>
             </a:pPr>
             <a:r>
-              <a:t>• 4 drawers: 🔵 understand, 🟢 search, 🟠 create, 🟣 organise-code.</a:t>
+              <a:t>• Need SOURCES: which drawer?</a:t>
             </a:r>
           </a:p>
           <a:p>
@@ -3575,7 +3590,7 @@
               </a:defRPr>
             </a:pPr>
             <a:r>
-              <a:t>• Tree: sources? → create? → organise-code? → else blue.</a:t>
+              <a:t>• Talk slides: which tool?</a:t>
             </a:r>
           </a:p>
           <a:p>
@@ -3587,7 +3602,7 @@
               </a:defRPr>
             </a:pPr>
             <a:r>
-              <a:t>• 1 favourite per drawer + AI Tools page bookmarked.</a:t>
+              <a:t>• Question YOUR own PDFs: which tool?</a:t>
             </a:r>
           </a:p>
         </p:txBody>
@@ -3626,10 +3641,10 @@
           <a:lstStyle/>
           <a:p>
             <a:r>
-              <a:t>🧠 Quiz éclair (3 questions)</a:t>
-            </a:r>
-            <a:r>
-              <a:t>  ·  Quick quiz</a:t>
+              <a:t>À retenir</a:t>
+            </a:r>
+            <a:r>
+              <a:t>  ·  Key takeaways</a:t>
             </a:r>
           </a:p>
         </p:txBody>
@@ -3653,35 +3668,39 @@
               <a:defRPr sz="2000"/>
             </a:pPr>
             <a:r>
-              <a:t>Q1. Besoin de SOURCES : quel tiroir ?</a:t>
-            </a:r>
-            <a:br/>
-            <a:r>
-              <a:t>   ✅ 🟢 Vert (Perplexity, Scholar)</a:t>
-            </a:r>
-          </a:p>
-          <a:p>
-            <a:pPr>
-              <a:defRPr sz="2000"/>
-            </a:pPr>
-            <a:r>
-              <a:t>Q2. Slides d'exposé : quel outil ?</a:t>
-            </a:r>
-            <a:br/>
-            <a:r>
-              <a:t>   ✅ Gamma (créer à montrer)</a:t>
-            </a:r>
-          </a:p>
-          <a:p>
-            <a:pPr>
-              <a:defRPr sz="2000"/>
-            </a:pPr>
-            <a:r>
-              <a:t>Q3. Interroger VOS propres PDF : quel outil ?</a:t>
-            </a:r>
-            <a:br/>
-            <a:r>
-              <a:t>   ✅ NotebookLM (vert : chercher dans vos documents)</a:t>
+              <a:t>4 tiroirs : 🔵🟢🟠🟣 valent mieux que 12 noms.</a:t>
+            </a:r>
+          </a:p>
+          <a:p>
+            <a:pPr>
+              <a:defRPr sz="2000"/>
+            </a:pPr>
+            <a:r>
+              <a:t>Arbre : sources ? créer ? organiser-coder ? sinon bleu.</a:t>
+            </a:r>
+          </a:p>
+          <a:p>
+            <a:pPr>
+              <a:defRPr sz="2000"/>
+            </a:pPr>
+            <a:r>
+              <a:t>Démo : même question, 3 outils, 3 métiers.</a:t>
+            </a:r>
+          </a:p>
+          <a:p>
+            <a:pPr>
+              <a:defRPr sz="2000"/>
+            </a:pPr>
+            <a:r>
+              <a:t>Gratuit étudiant d'abord ; 3 règles d'or partout.</a:t>
+            </a:r>
+          </a:p>
+          <a:p>
+            <a:pPr>
+              <a:defRPr sz="2000"/>
+            </a:pPr>
+            <a:r>
+              <a:t>Page Outils IA en favori : la pharmacie de poche.</a:t>
             </a:r>
           </a:p>
           <a:p/>
@@ -3706,7 +3725,7 @@
               </a:defRPr>
             </a:pPr>
             <a:r>
-              <a:t>• Need SOURCES: which drawer?</a:t>
+              <a:t>• 4 drawers: 🔵🟢🟠🟣 beat 12 names.</a:t>
             </a:r>
           </a:p>
           <a:p>
@@ -3718,7 +3737,7 @@
               </a:defRPr>
             </a:pPr>
             <a:r>
-              <a:t>• Talk slides: which tool?</a:t>
+              <a:t>• Tree: sources? create? organise-code? else blue.</a:t>
             </a:r>
           </a:p>
           <a:p>
@@ -3730,7 +3749,31 @@
               </a:defRPr>
             </a:pPr>
             <a:r>
-              <a:t>• Question YOUR own PDFs: which tool?</a:t>
+              <a:t>• Demo: same question, 3 tools, 3 jobs.</a:t>
+            </a:r>
+          </a:p>
+          <a:p>
+            <a:pPr lvl="1">
+              <a:defRPr sz="1300">
+                <a:solidFill>
+                  <a:srgbClr val="546E7A"/>
+                </a:solidFill>
+              </a:defRPr>
+            </a:pPr>
+            <a:r>
+              <a:t>• Student free first; 3 golden rules everywhere.</a:t>
+            </a:r>
+          </a:p>
+          <a:p>
+            <a:pPr lvl="1">
+              <a:defRPr sz="1300">
+                <a:solidFill>
+                  <a:srgbClr val="546E7A"/>
+                </a:solidFill>
+              </a:defRPr>
+            </a:pPr>
+            <a:r>
+              <a:t>• AI Tools page bookmarked: the pocket pharmacy.</a:t>
             </a:r>
           </a:p>
         </p:txBody>
@@ -3744,177 +3787,6 @@
 </file>
 
 <file path=ppt/slides/slide14.xml><?xml version="1.0" encoding="utf-8"?>
-<p:sld xmlns:a="http://schemas.openxmlformats.org/drawingml/2006/main" xmlns:p="http://schemas.openxmlformats.org/presentationml/2006/main" xmlns:r="http://schemas.openxmlformats.org/officeDocument/2006/relationships">
-  <p:cSld>
-    <p:spTree>
-      <p:nvGrpSpPr>
-        <p:cNvPr id="1" name=""/>
-        <p:cNvGrpSpPr/>
-        <p:nvPr/>
-      </p:nvGrpSpPr>
-      <p:grpSpPr/>
-      <p:sp>
-        <p:nvSpPr>
-          <p:cNvPr id="2" name="Title 1"/>
-          <p:cNvSpPr>
-            <a:spLocks noGrp="1"/>
-          </p:cNvSpPr>
-          <p:nvPr>
-            <p:ph type="title"/>
-          </p:nvPr>
-        </p:nvSpPr>
-        <p:spPr/>
-        <p:txBody>
-          <a:bodyPr/>
-          <a:lstStyle/>
-          <a:p>
-            <a:r>
-              <a:t>À retenir</a:t>
-            </a:r>
-            <a:r>
-              <a:t>  ·  Key takeaways</a:t>
-            </a:r>
-          </a:p>
-        </p:txBody>
-      </p:sp>
-      <p:sp>
-        <p:nvSpPr>
-          <p:cNvPr id="3" name="Content Placeholder 2"/>
-          <p:cNvSpPr>
-            <a:spLocks noGrp="1"/>
-          </p:cNvSpPr>
-          <p:nvPr>
-            <p:ph idx="1"/>
-          </p:nvPr>
-        </p:nvSpPr>
-        <p:spPr/>
-        <p:txBody>
-          <a:bodyPr wrap="square"/>
-          <a:lstStyle/>
-          <a:p>
-            <a:pPr>
-              <a:defRPr sz="2000"/>
-            </a:pPr>
-            <a:r>
-              <a:t>4 tiroirs : 🔵🟢🟠🟣 valent mieux que 12 noms.</a:t>
-            </a:r>
-          </a:p>
-          <a:p>
-            <a:pPr>
-              <a:defRPr sz="2000"/>
-            </a:pPr>
-            <a:r>
-              <a:t>Arbre : sources ? créer ? organiser-coder ? sinon bleu.</a:t>
-            </a:r>
-          </a:p>
-          <a:p>
-            <a:pPr>
-              <a:defRPr sz="2000"/>
-            </a:pPr>
-            <a:r>
-              <a:t>Démo : même question, 3 outils, 3 métiers.</a:t>
-            </a:r>
-          </a:p>
-          <a:p>
-            <a:pPr>
-              <a:defRPr sz="2000"/>
-            </a:pPr>
-            <a:r>
-              <a:t>Gratuit étudiant d'abord ; 3 règles d'or partout.</a:t>
-            </a:r>
-          </a:p>
-          <a:p>
-            <a:pPr>
-              <a:defRPr sz="2000"/>
-            </a:pPr>
-            <a:r>
-              <a:t>Page Outils IA en favori : la pharmacie de poche.</a:t>
-            </a:r>
-          </a:p>
-          <a:p/>
-          <a:p>
-            <a:pPr>
-              <a:defRPr sz="1300" i="1">
-                <a:solidFill>
-                  <a:srgbClr val="78899C"/>
-                </a:solidFill>
-              </a:defRPr>
-            </a:pPr>
-            <a:r>
-              <a:t>English summary:</a:t>
-            </a:r>
-          </a:p>
-          <a:p>
-            <a:pPr lvl="1">
-              <a:defRPr sz="1300">
-                <a:solidFill>
-                  <a:srgbClr val="546E7A"/>
-                </a:solidFill>
-              </a:defRPr>
-            </a:pPr>
-            <a:r>
-              <a:t>• 4 drawers: 🔵🟢🟠🟣 beat 12 names.</a:t>
-            </a:r>
-          </a:p>
-          <a:p>
-            <a:pPr lvl="1">
-              <a:defRPr sz="1300">
-                <a:solidFill>
-                  <a:srgbClr val="546E7A"/>
-                </a:solidFill>
-              </a:defRPr>
-            </a:pPr>
-            <a:r>
-              <a:t>• Tree: sources? create? organise-code? else blue.</a:t>
-            </a:r>
-          </a:p>
-          <a:p>
-            <a:pPr lvl="1">
-              <a:defRPr sz="1300">
-                <a:solidFill>
-                  <a:srgbClr val="546E7A"/>
-                </a:solidFill>
-              </a:defRPr>
-            </a:pPr>
-            <a:r>
-              <a:t>• Demo: same question, 3 tools, 3 jobs.</a:t>
-            </a:r>
-          </a:p>
-          <a:p>
-            <a:pPr lvl="1">
-              <a:defRPr sz="1300">
-                <a:solidFill>
-                  <a:srgbClr val="546E7A"/>
-                </a:solidFill>
-              </a:defRPr>
-            </a:pPr>
-            <a:r>
-              <a:t>• Student free first; 3 golden rules everywhere.</a:t>
-            </a:r>
-          </a:p>
-          <a:p>
-            <a:pPr lvl="1">
-              <a:defRPr sz="1300">
-                <a:solidFill>
-                  <a:srgbClr val="546E7A"/>
-                </a:solidFill>
-              </a:defRPr>
-            </a:pPr>
-            <a:r>
-              <a:t>• AI Tools page bookmarked: the pocket pharmacy.</a:t>
-            </a:r>
-          </a:p>
-        </p:txBody>
-      </p:sp>
-    </p:spTree>
-  </p:cSld>
-  <p:clrMapOvr>
-    <a:masterClrMapping/>
-  </p:clrMapOvr>
-</p:sld>
-</file>
-
-<file path=ppt/slides/slide15.xml><?xml version="1.0" encoding="utf-8"?>
 <p:sld xmlns:a="http://schemas.openxmlformats.org/drawingml/2006/main" xmlns:p="http://schemas.openxmlformats.org/presentationml/2006/main" xmlns:r="http://schemas.openxmlformats.org/officeDocument/2006/relationships">
   <p:cSld>
     <p:bg>
@@ -4071,39 +3943,39 @@
               <a:defRPr sz="2000"/>
             </a:pPr>
             <a:r>
-              <a:t>Classer les outils d'IA en 4 familles : comprendre, chercher, créer, organiser-coder.</a:t>
-            </a:r>
-          </a:p>
-          <a:p>
-            <a:pPr>
-              <a:defRPr sz="2000"/>
-            </a:pPr>
-            <a:r>
-              <a:t>Décrire en une phrase l'usage de chacun des 12 outils du module.</a:t>
-            </a:r>
-          </a:p>
-          <a:p>
-            <a:pPr>
-              <a:defRPr sz="2000"/>
-            </a:pPr>
-            <a:r>
-              <a:t>Comparer 3 outils en démonstration : assistant, moteur sourcé, création visuelle.</a:t>
-            </a:r>
-          </a:p>
-          <a:p>
-            <a:pPr>
-              <a:defRPr sz="2000"/>
-            </a:pPr>
-            <a:r>
-              <a:t>Choisir le bon outil pour une tâche avec l'arbre de décision.</a:t>
-            </a:r>
-          </a:p>
-          <a:p>
-            <a:pPr>
-              <a:defRPr sz="2000"/>
-            </a:pPr>
-            <a:r>
-              <a:t>Éviter les 3 erreurs de débutant : tout demander au même outil, croire sans vérifier, payer avant d'essayer le gratuit.</a:t>
+              <a:t>Ouvrir Perplexity sans créer de compte et y poser ta première question sourcée.</a:t>
+            </a:r>
+          </a:p>
+          <a:p>
+            <a:pPr>
+              <a:defRPr sz="2000"/>
+            </a:pPr>
+            <a:r>
+              <a:t>Tester 3 outils (ChatGPT, Perplexity, Canva) sur la même question et comparer.</a:t>
+            </a:r>
+          </a:p>
+          <a:p>
+            <a:pPr>
+              <a:defRPr sz="2000"/>
+            </a:pPr>
+            <a:r>
+              <a:t>Prescrire le bon outil pour 3 situations avec l'arbre de décision.</a:t>
+            </a:r>
+          </a:p>
+          <a:p>
+            <a:pPr>
+              <a:defRPr sz="2000"/>
+            </a:pPr>
+            <a:r>
+              <a:t>Choisir tes 4 outils favoris (1 par famille) et justifier chaque choix.</a:t>
+            </a:r>
+          </a:p>
+          <a:p>
+            <a:pPr>
+              <a:defRPr sz="2000"/>
+            </a:pPr>
+            <a:r>
+              <a:t>Éviter les 3 erreurs de débutant : sirop unique, confiance aveugle, abonnement aveugle.</a:t>
             </a:r>
           </a:p>
           <a:p/>
@@ -4128,7 +4000,7 @@
               </a:defRPr>
             </a:pPr>
             <a:r>
-              <a:t>• Sort AI tools into 4 families: understand, search, create, organise-code.</a:t>
+              <a:t>• Open Perplexity with no account and ask your first sourced question there.</a:t>
             </a:r>
           </a:p>
           <a:p>
@@ -4140,7 +4012,7 @@
               </a:defRPr>
             </a:pPr>
             <a:r>
-              <a:t>• Describe in one sentence the use of each of the module's 12 tools.</a:t>
+              <a:t>• Test 3 tools (ChatGPT, Perplexity, Canva) on the same question and compare.</a:t>
             </a:r>
           </a:p>
           <a:p>
@@ -4152,7 +4024,7 @@
               </a:defRPr>
             </a:pPr>
             <a:r>
-              <a:t>• Compare 3 tools in a demo: assistant, sourced engine, visual creation.</a:t>
+              <a:t>• Prescribe the right tool for 3 situations with the decision tree.</a:t>
             </a:r>
           </a:p>
           <a:p>
@@ -4164,7 +4036,7 @@
               </a:defRPr>
             </a:pPr>
             <a:r>
-              <a:t>• Pick the right tool for a task with the decision tree.</a:t>
+              <a:t>• Pick your 4 favourite tools (1 per family) and justify each pick.</a:t>
             </a:r>
           </a:p>
           <a:p>
@@ -4176,7 +4048,7 @@
               </a:defRPr>
             </a:pPr>
             <a:r>
-              <a:t>• Avoid 3 beginner mistakes: asking everything to one tool, believing without checking, paying before trying free.</a:t>
+              <a:t>• Avoid 3 beginner mistakes: single syrup, blind trust, blind subscription.</a:t>
             </a:r>
           </a:p>
         </p:txBody>
@@ -4242,47 +4114,47 @@
               <a:defRPr sz="2000"/>
             </a:pPr>
             <a:r>
-              <a:t>00–05 — Accroche : la jungle des 12 noms</a:t>
-            </a:r>
-          </a:p>
-          <a:p>
-            <a:pPr>
-              <a:defRPr sz="2000"/>
-            </a:pPr>
-            <a:r>
-              <a:t>05–25 — Explication : les 4 familles</a:t>
-            </a:r>
-          </a:p>
-          <a:p>
-            <a:pPr>
-              <a:defRPr sz="2000"/>
-            </a:pPr>
-            <a:r>
-              <a:t>25–50 — Démo : 3 outils en action</a:t>
-            </a:r>
-          </a:p>
-          <a:p>
-            <a:pPr>
-              <a:defRPr sz="2000"/>
-            </a:pPr>
-            <a:r>
-              <a:t>50–70 — Exercice guidé : le bon pharmacien</a:t>
-            </a:r>
-          </a:p>
-          <a:p>
-            <a:pPr>
-              <a:defRPr sz="2000"/>
-            </a:pPr>
-            <a:r>
-              <a:t>70–80 — Démo 2 : mauvais vs bon prompt</a:t>
-            </a:r>
-          </a:p>
-          <a:p>
-            <a:pPr>
-              <a:defRPr sz="2000"/>
-            </a:pPr>
-            <a:r>
-              <a:t>80–90 — Synthèse, quiz et annonce de la séance 3</a:t>
+              <a:t>00–05 — 🚀 Action immédiate : Perplexity sans compte</a:t>
+            </a:r>
+          </a:p>
+          <a:p>
+            <a:pPr>
+              <a:defRPr sz="2000"/>
+            </a:pPr>
+            <a:r>
+              <a:t>05–25 — 📋 Recette : tester 3 outils sur 1 question</a:t>
+            </a:r>
+          </a:p>
+          <a:p>
+            <a:pPr>
+              <a:defRPr sz="2000"/>
+            </a:pPr>
+            <a:r>
+              <a:t>25–50 — 🛠️ Démo : l'arbre de décision du pharmacien</a:t>
+            </a:r>
+          </a:p>
+          <a:p>
+            <a:pPr>
+              <a:defRPr sz="2000"/>
+            </a:pPr>
+            <a:r>
+              <a:t>50–70 — 🧪 Mission : tableau comparatif + 4 favoris</a:t>
+            </a:r>
+          </a:p>
+          <a:p>
+            <a:pPr>
+              <a:defRPr sz="2000"/>
+            </a:pPr>
+            <a:r>
+              <a:t>70–80 — ⚠️ Erreurs : sirop unique et confiance aveugle</a:t>
+            </a:r>
+          </a:p>
+          <a:p>
+            <a:pPr>
+              <a:defRPr sz="2000"/>
+            </a:pPr>
+            <a:r>
+              <a:t>80–90 — ✅ Checklist, quiz et annonce de la séance 3</a:t>
             </a:r>
           </a:p>
           <a:p/>
@@ -4307,7 +4179,7 @@
               </a:defRPr>
             </a:pPr>
             <a:r>
-              <a:t>• Hook: the 12-name jungle</a:t>
+              <a:t>• 🚀 Instant action: Perplexity with no account</a:t>
             </a:r>
           </a:p>
           <a:p>
@@ -4319,7 +4191,7 @@
               </a:defRPr>
             </a:pPr>
             <a:r>
-              <a:t>• Explanation: the 4 families</a:t>
+              <a:t>• 📋 Recipe: test 3 tools on 1 question</a:t>
             </a:r>
           </a:p>
           <a:p>
@@ -4331,7 +4203,7 @@
               </a:defRPr>
             </a:pPr>
             <a:r>
-              <a:t>• Demo: 3 tools in action</a:t>
+              <a:t>• 🛠️ Demo: the pharmacist's decision tree</a:t>
             </a:r>
           </a:p>
           <a:p>
@@ -4343,7 +4215,7 @@
               </a:defRPr>
             </a:pPr>
             <a:r>
-              <a:t>• Guided exercise: the good pharmacist</a:t>
+              <a:t>• 🧪 Mission: comparison table + 4 favourites</a:t>
             </a:r>
           </a:p>
           <a:p>
@@ -4355,7 +4227,7 @@
               </a:defRPr>
             </a:pPr>
             <a:r>
-              <a:t>• Demo 2: bad vs good prompt</a:t>
+              <a:t>• ⚠️ Mistakes: single syrup and blind trust</a:t>
             </a:r>
           </a:p>
           <a:p>
@@ -4367,7 +4239,7 @@
               </a:defRPr>
             </a:pPr>
             <a:r>
-              <a:t>• Wrap-up, quiz and preview of session 3</a:t>
+              <a:t>• ✅ Checklist, quiz and preview of session 3</a:t>
             </a:r>
           </a:p>
         </p:txBody>
@@ -4406,10 +4278,10 @@
           <a:lstStyle/>
           <a:p>
             <a:r>
-              <a:t>🎬 Accroche (5 min)</a:t>
-            </a:r>
-            <a:r>
-              <a:t>  ·  Hook</a:t>
+              <a:t>🎯 Ce que vous saurez faire à la fin</a:t>
+            </a:r>
+            <a:r>
+              <a:t>  ·  🎯 What you will be able to do by the end</a:t>
             </a:r>
           </a:p>
         </p:txBody>
@@ -4433,23 +4305,31 @@
               <a:defRPr sz="2000"/>
             </a:pPr>
             <a:r>
-              <a:t>❓ ChatGPT, Gemini, Perplexity, Canva, Notion… 12 noms sur le tableau : qui peut dire à quoi sert chacun ? Aujourd'hui, on range cette jungle.</a:t>
-            </a:r>
-          </a:p>
-          <a:p>
-            <a:pPr>
-              <a:defRPr sz="2000"/>
-            </a:pPr>
-            <a:r>
-              <a:t>🍳 🍳 Les outils d'IA, c'est comme la pharmacie : on ne soigne pas tout avec le même sirop. Le pharmacien (vous, bientôt) lit l'ordonnance (la tâche) puis choisit le bon flacon.</a:t>
-            </a:r>
-          </a:p>
-          <a:p>
-            <a:pPr>
-              <a:defRPr sz="2000"/>
-            </a:pPr>
-            <a:r>
-              <a:t>💡 💡 12 outils, 4 familles : COMPRENDRE (assistants), CHERCHER (moteurs sourcés), CRÉER (slides, images, voix), ORGANISER-CODER (notes, code, local).</a:t>
+              <a:t>Aujourd'hui, pas de théorie : tu vas TOUCHER à 3 outils. Voici les 3 résultats concrets de la séance.</a:t>
+            </a:r>
+          </a:p>
+          <a:p>
+            <a:pPr>
+              <a:defRPr sz="2000"/>
+            </a:pPr>
+            <a:r>
+              <a:t>&lt;strong&gt;1.&lt;/strong&gt; Ouvrir Perplexity SANS compte et obtenir une réponse avec des sources cliquables.</a:t>
+            </a:r>
+          </a:p>
+          <a:p>
+            <a:pPr>
+              <a:defRPr sz="2000"/>
+            </a:pPr>
+            <a:r>
+              <a:t>&lt;strong&gt;2.&lt;/strong&gt; Tester la même question sur 3 outils (ChatGPT, Perplexity, Canva) et dire lequel fait quoi.</a:t>
+            </a:r>
+          </a:p>
+          <a:p>
+            <a:pPr>
+              <a:defRPr sz="2000"/>
+            </a:pPr>
+            <a:r>
+              <a:t>&lt;strong&gt;3.&lt;/strong&gt; Repartir avec tes 4 outils favoris (1 par famille), chacun justifié en 1 phrase.</a:t>
             </a:r>
           </a:p>
           <a:p/>
@@ -4474,7 +4354,43 @@
               </a:defRPr>
             </a:pPr>
             <a:r>
-              <a:t>• 💡 12 tools, 4 families: UNDERSTAND (assistants), SEARCH (sourced engines), CREATE (slides, images, voice), ORGANISE-CODE (notes, code, local).</a:t>
+              <a:t>• Today, no theory: you will TOUCH 3 tools. Here are the 3 concrete results of the session.</a:t>
+            </a:r>
+          </a:p>
+          <a:p>
+            <a:pPr lvl="1">
+              <a:defRPr sz="1300">
+                <a:solidFill>
+                  <a:srgbClr val="546E7A"/>
+                </a:solidFill>
+              </a:defRPr>
+            </a:pPr>
+            <a:r>
+              <a:t>• &lt;strong&gt;1.&lt;/strong&gt; Open Perplexity with NO account and get an answer with clickable sources.</a:t>
+            </a:r>
+          </a:p>
+          <a:p>
+            <a:pPr lvl="1">
+              <a:defRPr sz="1300">
+                <a:solidFill>
+                  <a:srgbClr val="546E7A"/>
+                </a:solidFill>
+              </a:defRPr>
+            </a:pPr>
+            <a:r>
+              <a:t>• &lt;strong&gt;2.&lt;/strong&gt; Test the same question on 3 tools (ChatGPT, Perplexity, Canva) and say which does what.</a:t>
+            </a:r>
+          </a:p>
+          <a:p>
+            <a:pPr lvl="1">
+              <a:defRPr sz="1300">
+                <a:solidFill>
+                  <a:srgbClr val="546E7A"/>
+                </a:solidFill>
+              </a:defRPr>
+            </a:pPr>
+            <a:r>
+              <a:t>• &lt;strong&gt;3.&lt;/strong&gt; Leave with your 4 favourite tools (1 per family), each justified in 1 sentence.</a:t>
             </a:r>
           </a:p>
         </p:txBody>
@@ -4513,10 +4429,10 @@
           <a:lstStyle/>
           <a:p>
             <a:r>
-              <a:t>Les 4 familles : rangez la jungle</a:t>
-            </a:r>
-            <a:r>
-              <a:t>  ·  The 4 families: tidy the jungle</a:t>
+              <a:t>🚀 Action immédiate — Perplexity sans compte (5 minutes)</a:t>
+            </a:r>
+            <a:r>
+              <a:t>  ·  🚀 Instant action — Perplexity with no account (5 minutes)</a:t>
             </a:r>
           </a:p>
         </p:txBody>
@@ -4540,7 +4456,7 @@
               <a:defRPr sz="2000"/>
             </a:pPr>
             <a:r>
-              <a:t>Retenez 4 tiroirs, pas 12 noms. Devant chaque tâche, demandez-vous : est-ce que je veux COMPRENDRE, CHERCHER, CRÉER ou ORGANISER-CODER ? Le tiroir désigne l'outil.</a:t>
+              <a:t>Bonne nouvelle : Perplexity marche SANS inscription. En 5 minutes, tu obtiendras ta première réponse SOURCÉE.</a:t>
             </a:r>
           </a:p>
           <a:p/>
@@ -4565,7 +4481,7 @@
               </a:defRPr>
             </a:pPr>
             <a:r>
-              <a:t>• Remember 4 drawers, not 12 names. Before each task, ask: do I want to UNDERSTAND, SEARCH, CREATE or ORGANISE-CODE? The drawer points to the tool.</a:t>
+              <a:t>• Good news: Perplexity works with NO signup. In 5 minutes, you will get your first SOURCED answer.</a:t>
             </a:r>
           </a:p>
         </p:txBody>
@@ -4604,10 +4520,10 @@
           <a:lstStyle/>
           <a:p>
             <a:r>
-              <a:t>Les 12 outils en fiches express</a:t>
-            </a:r>
-            <a:r>
-              <a:t>  ·  The 12 tools in flash sheets</a:t>
+              <a:t>📋 Recette : 3 outils, 1 question, 1 verdict</a:t>
+            </a:r>
+            <a:r>
+              <a:t>  ·  📋 Recipe: 3 tools, 1 question, 1 verdict</a:t>
             </a:r>
           </a:p>
         </p:txBody>
@@ -4631,47 +4547,47 @@
               <a:defRPr sz="2000"/>
             </a:pPr>
             <a:r>
-              <a:t>Une phrase par outil, à connaître par cœur. Le détail complet (étapes, forces, limites) est sur la page « Outils IA » du module : chaque outil y a sa fiche.</a:t>
-            </a:r>
-          </a:p>
-          <a:p>
-            <a:pPr>
-              <a:defRPr sz="2000"/>
-            </a:pPr>
-            <a:r>
-              <a:t>&lt;strong&gt;ChatGPT :&lt;/strong&gt; l'assistant généraliste qui explique, résume et rédige.</a:t>
-            </a:r>
-          </a:p>
-          <a:p>
-            <a:pPr>
-              <a:defRPr sz="2000"/>
-            </a:pPr>
-            <a:r>
-              <a:t>&lt;strong&gt;Gemini :&lt;/strong&gt; comme ChatGPT + lit images et PDF.</a:t>
-            </a:r>
-          </a:p>
-          <a:p>
-            <a:pPr>
-              <a:defRPr sz="2000"/>
-            </a:pPr>
-            <a:r>
-              <a:t>&lt;strong&gt;Claude :&lt;/strong&gt; le champion des longs textes en bon français.</a:t>
-            </a:r>
-          </a:p>
-          <a:p>
-            <a:pPr>
-              <a:defRPr sz="2000"/>
-            </a:pPr>
-            <a:r>
-              <a:t>&lt;strong&gt;Perplexity :&lt;/strong&gt; répond AVEC les sources à ouvrir.</a:t>
-            </a:r>
-          </a:p>
-          <a:p>
-            <a:pPr>
-              <a:defRPr sz="2000"/>
-            </a:pPr>
-            <a:r>
-              <a:t>&lt;strong&gt;Scholar / Consensus :&lt;/strong&gt; la bibliothèque scientifique (articles, consensus).</a:t>
+              <a:t>Étape 0 — range d'abord : 4 tiroirs, pas 12 noms. Devant chaque tâche : COMPRENDRE, CHERCHER, CRÉER ou ORGANISER-CODER ? Le tiroir désigne l'outil.</a:t>
+            </a:r>
+          </a:p>
+          <a:p>
+            <a:pPr>
+              <a:defRPr sz="2000"/>
+            </a:pPr>
+            <a:r>
+              <a:t>Détail complet de chaque outil sur la page « Outils IA » du module. Maintenant, teste : même question, 3 outils, 1 verdict.</a:t>
+            </a:r>
+          </a:p>
+          <a:p>
+            <a:pPr>
+              <a:defRPr sz="2000"/>
+            </a:pPr>
+            <a:r>
+              <a:t>&lt;strong&gt;ChatGPT (🔵) :&lt;/strong&gt; explication claire + exemple, sans sources. Parfait pour COMPRENDRE vite.</a:t>
+            </a:r>
+          </a:p>
+          <a:p>
+            <a:pPr>
+              <a:defRPr sz="2000"/>
+            </a:pPr>
+            <a:r>
+              <a:t>&lt;strong&gt;Perplexity (🟢) :&lt;/strong&gt; réponse plus courte MAIS avec 3 liens : parfait pour VÉRIFIER et citer.</a:t>
+            </a:r>
+          </a:p>
+          <a:p>
+            <a:pPr>
+              <a:defRPr sz="2000"/>
+            </a:pPr>
+            <a:r>
+              <a:t>&lt;strong&gt;Canva IA (🟠) :&lt;/strong&gt; une affiche « différenciation » pour la classe : parfait pour MONTRER.</a:t>
+            </a:r>
+          </a:p>
+          <a:p>
+            <a:pPr>
+              <a:defRPr sz="2000"/>
+            </a:pPr>
+            <a:r>
+              <a:t>&lt;strong&gt;Leçon :&lt;/strong&gt; comprendre → bleu ; prouver → vert ; montrer → orange. Trois outils, trois métiers.</a:t>
             </a:r>
           </a:p>
           <a:p/>
@@ -4696,7 +4612,7 @@
               </a:defRPr>
             </a:pPr>
             <a:r>
-              <a:t>• One sentence per tool, to know by heart. Full detail (steps, strengths, limits) is on the module's "AI Tools" page: each tool has its sheet there.</a:t>
+              <a:t>• Step 0 — sort first: 4 drawers, not 12 names. Before each task: UNDERSTAND, SEARCH, CREATE or ORGANISE-CODE? The drawer points to the tool.</a:t>
             </a:r>
           </a:p>
           <a:p>
@@ -4708,7 +4624,7 @@
               </a:defRPr>
             </a:pPr>
             <a:r>
-              <a:t>• &lt;strong&gt;ChatGPT:&lt;/strong&gt; the generalist assistant explaining, summarising, writing.</a:t>
+              <a:t>• Full detail of each tool on the module's "AI Tools" page. Now test: same question, 3 tools, 1 verdict.</a:t>
             </a:r>
           </a:p>
           <a:p>
@@ -4720,7 +4636,7 @@
               </a:defRPr>
             </a:pPr>
             <a:r>
-              <a:t>• &lt;strong&gt;Gemini:&lt;/strong&gt; like ChatGPT + reads images and PDFs.</a:t>
+              <a:t>• &lt;strong&gt;ChatGPT (🔵):&lt;/strong&gt; clear explanation + example, no sources. Perfect to UNDERSTAND fast.</a:t>
             </a:r>
           </a:p>
           <a:p>
@@ -4732,7 +4648,7 @@
               </a:defRPr>
             </a:pPr>
             <a:r>
-              <a:t>• &lt;strong&gt;Claude:&lt;/strong&gt; the champion of long texts in good French.</a:t>
+              <a:t>• &lt;strong&gt;Perplexity (🟢):&lt;/strong&gt; shorter answer BUT with 3 links: perfect to CHECK and cite.</a:t>
             </a:r>
           </a:p>
         </p:txBody>
@@ -4771,10 +4687,10 @@
           <a:lstStyle/>
           <a:p>
             <a:r>
-              <a:t>Démo : la même question à 3 outils</a:t>
-            </a:r>
-            <a:r>
-              <a:t>  ·  Demo: the same question to 3 tools</a:t>
+              <a:t>⚠️ Erreurs fréquentes des pharmaciens débutants</a:t>
+            </a:r>
+            <a:r>
+              <a:t>  ·  ⚠️ Frequent rookie-pharmacist mistakes</a:t>
             </a:r>
           </a:p>
         </p:txBody>
@@ -4798,39 +4714,31 @@
               <a:defRPr sz="2000"/>
             </a:pPr>
             <a:r>
-              <a:t>Question test : « Explique la différenciation pédagogique avec un exemple de primaire. » Regardez ce que CHAQUE outil apporte — aucun ne fait tout.</a:t>
-            </a:r>
-          </a:p>
-          <a:p>
-            <a:pPr>
-              <a:defRPr sz="2000"/>
-            </a:pPr>
-            <a:r>
-              <a:t>&lt;strong&gt;ChatGPT (🔵) :&lt;/strong&gt; explication claire + exemple, sans sources. Parfait pour COMPRENDRE vite.</a:t>
-            </a:r>
-          </a:p>
-          <a:p>
-            <a:pPr>
-              <a:defRPr sz="2000"/>
-            </a:pPr>
-            <a:r>
-              <a:t>&lt;strong&gt;Perplexity (🟢) :&lt;/strong&gt; réponse plus courte MAIS avec 3 liens : parfait pour VÉRIFIER et citer.</a:t>
-            </a:r>
-          </a:p>
-          <a:p>
-            <a:pPr>
-              <a:defRPr sz="2000"/>
-            </a:pPr>
-            <a:r>
-              <a:t>&lt;strong&gt;Canva IA (🟠) :&lt;/strong&gt; une affiche « différenciation » pour la classe : parfait pour MONTRER.</a:t>
-            </a:r>
-          </a:p>
-          <a:p>
-            <a:pPr>
-              <a:defRPr sz="2000"/>
-            </a:pPr>
-            <a:r>
-              <a:t>&lt;strong&gt;Leçon :&lt;/strong&gt; comprendre → bleu ; prouver → vert ; montrer → orange. Trois outils, trois métiers.</a:t>
+              <a:t>Vérifie ton tableau comparatif : as-tu commis l'une de ces 3 erreurs ? Corrige-la tout de suite sur ton écran.</a:t>
+            </a:r>
+          </a:p>
+          <a:p>
+            <a:pPr>
+              <a:defRPr sz="2000"/>
+            </a:pPr>
+            <a:r>
+              <a:t>&lt;strong&gt;❌ Le sirop unique :&lt;/strong&gt; tout demander au même outil. &lt;strong&gt;✅ Prescris&lt;/strong&gt; avec l'arbre : sources ? → 🟢 ; créer ? → 🟠 ; organiser-coder ? → 🟣 ; sinon 🔵.</a:t>
+            </a:r>
+          </a:p>
+          <a:p>
+            <a:pPr>
+              <a:defRPr sz="2000"/>
+            </a:pPr>
+            <a:r>
+              <a:t>&lt;strong&gt;❌ Croire sans ouvrir :&lt;/strong&gt; la réponse a l'air sûre, mais les liens ? &lt;strong&gt;✅ Ouvre&lt;/strong&gt; au moins 1 source avant de noter quoi que ce soit.</a:t>
+            </a:r>
+          </a:p>
+          <a:p>
+            <a:pPr>
+              <a:defRPr sz="2000"/>
+            </a:pPr>
+            <a:r>
+              <a:t>&lt;strong&gt;❌ Payer avant d'essayer :&lt;/strong&gt; cliquer « Premium » par impatience. &lt;strong&gt;✅ Épuise&lt;/strong&gt; d'abord le gratuit étudiant (largement suffisant pour ce module).</a:t>
             </a:r>
           </a:p>
           <a:p/>
@@ -4855,7 +4763,7 @@
               </a:defRPr>
             </a:pPr>
             <a:r>
-              <a:t>• Test question: "Explain pedagogical differentiation with a primary example." Watch what EACH tool brings — none does everything.</a:t>
+              <a:t>• Check your comparison table: did you make one of these 3 mistakes? Fix it right now on your screen.</a:t>
             </a:r>
           </a:p>
           <a:p>
@@ -4867,7 +4775,7 @@
               </a:defRPr>
             </a:pPr>
             <a:r>
-              <a:t>• &lt;strong&gt;ChatGPT (🔵):&lt;/strong&gt; clear explanation + example, no sources. Perfect to UNDERSTAND fast.</a:t>
+              <a:t>• &lt;strong&gt;❌ The single syrup:&lt;/strong&gt; asking everything to one tool. &lt;strong&gt;✅ Prescribe&lt;/strong&gt; with the tree: sources? → 🟢; create? → 🟠; organise-code? → 🟣; else 🔵.</a:t>
             </a:r>
           </a:p>
           <a:p>
@@ -4879,7 +4787,7 @@
               </a:defRPr>
             </a:pPr>
             <a:r>
-              <a:t>• &lt;strong&gt;Perplexity (🟢):&lt;/strong&gt; shorter answer BUT with 3 links: perfect to CHECK and cite.</a:t>
+              <a:t>• &lt;strong&gt;❌ Believing without opening:&lt;/strong&gt; the answer looks sure, but the links? &lt;strong&gt;✅ Open&lt;/strong&gt; at least 1 source before noting anything.</a:t>
             </a:r>
           </a:p>
           <a:p>
@@ -4891,7 +4799,7 @@
               </a:defRPr>
             </a:pPr>
             <a:r>
-              <a:t>• &lt;strong&gt;Canva AI (🟠):&lt;/strong&gt; a "differentiation" poster for class: perfect to SHOW.</a:t>
+              <a:t>• &lt;strong&gt;❌ Paying before trying:&lt;/strong&gt; clicking "Premium" impatiently. &lt;strong&gt;✅ Exhaust&lt;/strong&gt; student free tiers first (plenty for this module).</a:t>
             </a:r>
           </a:p>
         </p:txBody>
@@ -4930,10 +4838,10 @@
           <a:lstStyle/>
           <a:p>
             <a:r>
-              <a:t>Bien choisir : l'arbre de décision du pharmacien</a:t>
-            </a:r>
-            <a:r>
-              <a:t>  ·  Choose well: the pharmacist's decision tree</a:t>
+              <a:t>🧪 Votre mission — ordonnance complète</a:t>
+            </a:r>
+            <a:r>
+              <a:t>  ·  🧪 Your mission — full prescription</a:t>
             </a:r>
           </a:p>
         </p:txBody>
@@ -4957,7 +4865,7 @@
               <a:defRPr sz="2000"/>
             </a:pPr>
             <a:r>
-              <a:t>Trois questions suffisent pour ne plus jamais se tromper d'outil.</a:t>
+              <a:t>En binôme, produisez UNE page : votre ordonnance pour 1 vraie question de cours. À rendre au début de la séance 3.</a:t>
             </a:r>
           </a:p>
           <a:p/>
@@ -4982,7 +4890,7 @@
               </a:defRPr>
             </a:pPr>
             <a:r>
-              <a:t>• Three questions are enough to never pick the wrong tool again.</a:t>
+              <a:t>• In pairs, produce ONE page: your prescription for 1 real lesson question. Hand it in at the start of session 3.</a:t>
             </a:r>
           </a:p>
         </p:txBody>
@@ -5021,10 +4929,10 @@
           <a:lstStyle/>
           <a:p>
             <a:r>
-              <a:t>Comment en profiter au maximum</a:t>
-            </a:r>
-            <a:r>
-              <a:t>  ·  How to get the most out of it</a:t>
+              <a:t>✅ Checklist de validation</a:t>
+            </a:r>
+            <a:r>
+              <a:t>  ·  ✅ Validation checklist</a:t>
             </a:r>
           </a:p>
         </p:txBody>
@@ -5048,39 +4956,39 @@
               <a:defRPr sz="2000"/>
             </a:pPr>
             <a:r>
-              <a:t>Le bon pharmacien ne connaît pas 12 sirops par cœur le premier jour : il connaît 4 tiroirs, 1 outil préféré par tiroir, et la page « Outils IA » pour le reste.</a:t>
-            </a:r>
-          </a:p>
-          <a:p>
-            <a:pPr>
-              <a:defRPr sz="2000"/>
-            </a:pPr>
-            <a:r>
-              <a:t>&lt;strong&gt;✅ 1 favori par tiroir :&lt;/strong&gt; choisissez vos 4 outils de tous les jours cette semaine.</a:t>
-            </a:r>
-          </a:p>
-          <a:p>
-            <a:pPr>
-              <a:defRPr sz="2000"/>
-            </a:pPr>
-            <a:r>
-              <a:t>&lt;strong&gt;✅ Gratuit d'abord :&lt;/strong&gt; comptes étudiants gratuits avant tout abonnement.</a:t>
-            </a:r>
-          </a:p>
-          <a:p>
-            <a:pPr>
-              <a:defRPr sz="2000"/>
-            </a:pPr>
-            <a:r>
-              <a:t>&lt;strong&gt;✅ Fiche outils :&lt;/strong&gt; gardez la page « Outils IA » en favori du navigateur.</a:t>
-            </a:r>
-          </a:p>
-          <a:p>
-            <a:pPr>
-              <a:defRPr sz="2000"/>
-            </a:pPr>
-            <a:r>
-              <a:t>&lt;strong&gt;✅ Testez à deux :&lt;/strong&gt; même question, deux outils, comparez — le meilleur exercice.</a:t>
+              <a:t>Avant de partir, coche avec ton binôme. Tout doit être coché :</a:t>
+            </a:r>
+          </a:p>
+          <a:p>
+            <a:pPr>
+              <a:defRPr sz="2000"/>
+            </a:pPr>
+            <a:r>
+              <a:t>☐ J'ai ouvert Perplexity SANS compte et obtenu une réponse sourcée.</a:t>
+            </a:r>
+          </a:p>
+          <a:p>
+            <a:pPr>
+              <a:defRPr sz="2000"/>
+            </a:pPr>
+            <a:r>
+              <a:t>☐ J'ai testé 1 question sur 2 outils et rempli le tableau comparatif.</a:t>
+            </a:r>
+          </a:p>
+          <a:p>
+            <a:pPr>
+              <a:defRPr sz="2000"/>
+            </a:pPr>
+            <a:r>
+              <a:t>☐ J'ai prescrit le bon tiroir avec l'arbre (sources ? créer ? organiser ?).</a:t>
+            </a:r>
+          </a:p>
+          <a:p>
+            <a:pPr>
+              <a:defRPr sz="2000"/>
+            </a:pPr>
+            <a:r>
+              <a:t>☐ J'ai repéré 1 limite (pas de sources, réponse inventée, compte exigé).</a:t>
             </a:r>
           </a:p>
           <a:p/>
@@ -5105,7 +5013,7 @@
               </a:defRPr>
             </a:pPr>
             <a:r>
-              <a:t>• The good pharmacist does not memorise 12 syrups on day one: he knows 4 drawers, 1 favourite tool per drawer, and the "AI Tools" page for the rest.</a:t>
+              <a:t>• Before leaving, tick with your partner. Everything must be ticked:</a:t>
             </a:r>
           </a:p>
           <a:p>
@@ -5117,7 +5025,7 @@
               </a:defRPr>
             </a:pPr>
             <a:r>
-              <a:t>• &lt;strong&gt;✅ 1 favourite per drawer:&lt;/strong&gt; pick your 4 everyday tools this week.</a:t>
+              <a:t>• ☐ I opened Perplexity with NO account and got a sourced answer.</a:t>
             </a:r>
           </a:p>
           <a:p>
@@ -5129,7 +5037,7 @@
               </a:defRPr>
             </a:pPr>
             <a:r>
-              <a:t>• &lt;strong&gt;✅ Free first:&lt;/strong&gt; free student accounts before any subscription.</a:t>
+              <a:t>• ☐ I tested 1 question on 2 tools and filled the comparison table.</a:t>
             </a:r>
           </a:p>
           <a:p>
@@ -5141,7 +5049,7 @@
               </a:defRPr>
             </a:pPr>
             <a:r>
-              <a:t>• &lt;strong&gt;✅ Tools sheet:&lt;/strong&gt; bookmark the "AI Tools" page in your browser.</a:t>
+              <a:t>• ☐ I prescribed the right drawer with the tree (sources? create? organise?).</a:t>
             </a:r>
           </a:p>
         </p:txBody>

</xml_diff>